<commit_message>
Corrections: LangChain SQL Tool, PostgreSQL, CSV RAGAS versionnés, seuils RAGAS, fix Python 3.12
</commit_message>
<xml_diff>
--- a/Soutenance_SportSee_NBA_Analyst_AI.pptx
+++ b/Soutenance_SportSee_NBA_Analyst_AI.pptx
@@ -16,9 +16,10 @@
     <p:sldId id="264" r:id="rId10"/>
     <p:sldId id="265" r:id="rId11"/>
     <p:sldId id="266" r:id="rId12"/>
+    <p:sldId id="267" r:id="rId13"/>
   </p:sldIdLst>
   <p:notesMasterIdLst>
-    <p:notesMasterId r:id="rId13"/>
+    <p:notesMasterId r:id="rId14"/>
   </p:notesMasterIdLst>
   <p:sldSz cx="12192000" cy="6858000"/>
   <p:notesSz cx="6858000" cy="12192000"/>
@@ -961,7 +962,7 @@
           <a:p>
             <a:r>
               <a:rPr lang="en-US" dirty="0"/>
-              <a:t>Je préfère assumer ces limites explicitement plutôt que de présenter un score parfait qui ne résisterait pas à un examen approfondi — c'est d'ailleurs toute la démarche de ce rapport.</a:t>
+              <a:t>Le système intègre aussi un OCR de secours pour les rapports scannés, et un outil de visualisation dynamique. J'ai gardé le même principe de sécurité que pour le SQL Tool : aucun de ces deux composants ne peut inventer une donnée — l'OCR échoue proprement sans clé API, et le PlotTool ne trace que des chiffres déjà vérifiés par le SQL Tool.</a:t>
             </a:r>
             <a:endParaRPr lang="en-US" dirty="0"/>
           </a:p>
@@ -1049,7 +1050,7 @@
           <a:p>
             <a:r>
               <a:rPr lang="en-US" dirty="0"/>
-              <a:t>Pour conclure : le SQL Tool comble un vrai manque du RAG textuel seul, et je peux le prouver avec des chiffres plutôt qu'une affirmation — c'était l'objectif de cette mission. Je suis prête à répondre à vos questions.</a:t>
+              <a:t>Je préfère assumer ces limites explicitement plutôt que de présenter un score parfait qui ne résisterait pas à un examen approfondi — c'est d'ailleurs toute la démarche de ce rapport.</a:t>
             </a:r>
             <a:endParaRPr lang="en-US" dirty="0"/>
           </a:p>
@@ -1073,6 +1074,94 @@
             <a:fld id="{F7021451-1387-4CA6-816F-3879F97B5CBC}" type="slidenum">
               <a:rPr lang="en-US"/>
               <a:t>11</a:t>
+            </a:fld>
+            <a:endParaRPr lang="en-US"/>
+          </a:p>
+        </p:txBody>
+      </p:sp>
+    </p:spTree>
+    <p:extLst>
+      <p:ext uri="{BB962C8B-B14F-4D97-AF65-F5344CB8AC3E}">
+        <p14:creationId xmlns:p14="http://schemas.microsoft.com/office/powerpoint/2010/main" val="1024086991"/>
+      </p:ext>
+    </p:extLst>
+  </p:cSld>
+  <p:clrMapOvr>
+    <a:masterClrMapping/>
+  </p:clrMapOvr>
+</p:notes>
+</file>
+
+<file path=ppt/notesSlides/notesSlide12.xml><?xml version="1.0" encoding="utf-8"?>
+<p:notes xmlns:a="http://schemas.openxmlformats.org/drawingml/2006/main" xmlns:r="http://schemas.openxmlformats.org/officeDocument/2006/relationships" xmlns:p="http://schemas.openxmlformats.org/presentationml/2006/main">
+  <p:cSld>
+    <p:spTree>
+      <p:nvGrpSpPr>
+        <p:cNvPr id="1" name=""/>
+        <p:cNvGrpSpPr/>
+        <p:nvPr/>
+      </p:nvGrpSpPr>
+      <p:grpSpPr>
+        <a:xfrm>
+          <a:off x="0" y="0"/>
+          <a:ext cx="0" cy="0"/>
+          <a:chOff x="0" y="0"/>
+          <a:chExt cx="0" cy="0"/>
+        </a:xfrm>
+      </p:grpSpPr>
+      <p:sp>
+        <p:nvSpPr>
+          <p:cNvPr id="2" name="Slide Image Placeholder 1"/>
+          <p:cNvSpPr>
+            <a:spLocks noGrp="1" noRot="1" noChangeAspect="1"/>
+          </p:cNvSpPr>
+          <p:nvPr>
+            <p:ph type="sldImg"/>
+          </p:nvPr>
+        </p:nvSpPr>
+        <p:spPr/>
+      </p:sp>
+      <p:sp>
+        <p:nvSpPr>
+          <p:cNvPr id="3" name="Notes Placeholder 2"/>
+          <p:cNvSpPr>
+            <a:spLocks noGrp="1"/>
+          </p:cNvSpPr>
+          <p:nvPr>
+            <p:ph type="body" idx="1"/>
+          </p:nvPr>
+        </p:nvSpPr>
+        <p:spPr/>
+        <p:txBody>
+          <a:bodyPr/>
+          <a:lstStyle/>
+          <a:p>
+            <a:r>
+              <a:rPr lang="en-US" dirty="0"/>
+              <a:t>Pour conclure : le SQL Tool comble un vrai manque du RAG textuel seul, et je peux le prouver avec des chiffres plutôt qu'une affirmation — c'était l'objectif de cette mission. Je suis prête à répondre à vos questions.</a:t>
+            </a:r>
+            <a:endParaRPr lang="en-US" dirty="0"/>
+          </a:p>
+        </p:txBody>
+      </p:sp>
+      <p:sp>
+        <p:nvSpPr>
+          <p:cNvPr id="4" name="Slide Number Placeholder 3"/>
+          <p:cNvSpPr>
+            <a:spLocks noGrp="1"/>
+          </p:cNvSpPr>
+          <p:nvPr>
+            <p:ph type="sldNum" sz="quarter" idx="10"/>
+          </p:nvPr>
+        </p:nvSpPr>
+        <p:spPr/>
+        <p:txBody>
+          <a:bodyPr/>
+          <a:lstStyle/>
+          <a:p>
+            <a:fld id="{F7021451-1387-4CA6-816F-3879F97B5CBC}" type="slidenum">
+              <a:rPr lang="en-US"/>
+              <a:t>12</a:t>
             </a:fld>
             <a:endParaRPr lang="en-US"/>
           </a:p>
@@ -1225,7 +1314,7 @@
           <a:p>
             <a:r>
               <a:rPr lang="en-US" dirty="0"/>
-              <a:t>Le routeur, construit avec Pydantic AI, décide automatiquement si une question a besoin du contexte texte, du SQL Tool, ou des deux. Le SQL Tool ne génère jamais de requête destructrice : validation Pydantic en entrée, SELECT uniquement, limite de lignes, et surtout un mécanisme NO_DATA pour refuser plutôt qu'inventer quand la donnée n'existe pas.</a:t>
+              <a:t>Le routeur, construit avec Pydantic AI, décide automatiquement si une question a besoin du contexte texte, du SQL Tool, ou des deux. Le SQL Tool génère sa requête via LangChain (create_sql_query_chain + ChatMistralAI), avec un repli automatique sur un appel direct au SDK Mistral si LangChain échoue. Il ne génère jamais de requête destructrice : validation Pydantic en entrée, SELECT uniquement, limite de lignes, et surtout un mécanisme NO_DATA pour refuser plutôt qu'inventer quand la donnée n'existe pas. La base de données est PostgreSQL.</a:t>
             </a:r>
             <a:endParaRPr lang="en-US" dirty="0"/>
           </a:p>
@@ -1753,7 +1842,7 @@
           <a:p>
             <a:r>
               <a:rPr lang="en-US" dirty="0"/>
-              <a:t>Le système intègre aussi un OCR de secours pour les rapports scannés, et un outil de visualisation dynamique. J'ai gardé le même principe de sécurité que pour le SQL Tool : aucun de ces deux composants ne peut inventer une donnée — l'OCR échoue proprement sans clé API, et le PlotTool ne trace que des chiffres déjà vérifiés par le SQL Tool.</a:t>
+              <a:t>Cette diapositive est un emplacement réservé : à remplacer par une vraie capture d'écran de mon dashboard Logfire avant la soutenance (ou à montrer en direct, ce qui est explicitement attendu). Logfire trace chaque étape du pipeline — recherche vectorielle, génération et exécution SQL via LangChain, génération finale Mistral — ce qui m'a permis de détecter plusieurs bugs réels en conditions d'usage, documentés dans le rapport (ex: l'incohérence needs_plot/needs_sql).</a:t>
             </a:r>
             <a:endParaRPr lang="en-US" dirty="0"/>
           </a:p>
@@ -2453,7 +2542,7 @@
                 <a:ea typeface="Cambria" pitchFamily="34" charset="-122"/>
                 <a:cs typeface="Cambria" pitchFamily="34" charset="-120"/>
               </a:rPr>
-              <a:t>Limites et pistes d’amélioration</a:t>
+              <a:t>OCR et visualisation dynamique</a:t>
             </a:r>
             <a:endParaRPr lang="en-US" sz="3200" dirty="0"/>
           </a:p>
@@ -2461,17 +2550,58 @@
       </p:sp>
       <p:sp>
         <p:nvSpPr>
-          <p:cNvPr id="3" name="Shape 1"/>
-          <p:cNvSpPr/>
-          <p:nvPr/>
-        </p:nvSpPr>
-        <p:spPr>
-          <a:xfrm>
-            <a:off x="548640" y="1737360"/>
-            <a:ext cx="502920" cy="502920"/>
-          </a:xfrm>
-          <a:prstGeom prst="ellipse">
-            <a:avLst/>
+          <p:cNvPr id="3" name="Text 1"/>
+          <p:cNvSpPr/>
+          <p:nvPr/>
+        </p:nvSpPr>
+        <p:spPr>
+          <a:xfrm>
+            <a:off x="548640" y="960120"/>
+            <a:ext cx="11064240" cy="365760"/>
+          </a:xfrm>
+          <a:prstGeom prst="rect">
+            <a:avLst/>
+          </a:prstGeom>
+          <a:noFill/>
+          <a:ln/>
+        </p:spPr>
+        <p:txBody>
+          <a:bodyPr wrap="square" lIns="0" tIns="0" rIns="0" bIns="0" rtlCol="0" anchor="ctr"/>
+          <a:lstStyle/>
+          <a:p>
+            <a:pPr indent="0" marL="0">
+              <a:buNone/>
+            </a:pPr>
+            <a:r>
+              <a:rPr lang="en-US" sz="1400" dirty="0">
+                <a:solidFill>
+                  <a:srgbClr val="6B7280"/>
+                </a:solidFill>
+                <a:latin typeface="Calibri" pitchFamily="34" charset="0"/>
+                <a:ea typeface="Calibri" pitchFamily="34" charset="-122"/>
+                <a:cs typeface="Calibri" pitchFamily="34" charset="-120"/>
+              </a:rPr>
+              <a:t>Deux composants du système, au même niveau d’exigence que le SQL Tool</a:t>
+            </a:r>
+            <a:endParaRPr lang="en-US" sz="1400" dirty="0"/>
+          </a:p>
+        </p:txBody>
+      </p:sp>
+      <p:sp>
+        <p:nvSpPr>
+          <p:cNvPr id="4" name="Shape 2"/>
+          <p:cNvSpPr/>
+          <p:nvPr/>
+        </p:nvSpPr>
+        <p:spPr>
+          <a:xfrm>
+            <a:off x="548640" y="1508760"/>
+            <a:ext cx="5349240" cy="4480560"/>
+          </a:xfrm>
+          <a:prstGeom prst="roundRect">
+            <a:avLst>
+              <a:gd name="adj" fmla="val 2041"/>
+            </a:avLst>
           </a:prstGeom>
           <a:solidFill>
             <a:srgbClr val="F4F6FC"/>
@@ -2479,9 +2609,29 @@
           <a:ln/>
         </p:spPr>
       </p:sp>
+      <p:sp>
+        <p:nvSpPr>
+          <p:cNvPr id="5" name="Shape 3"/>
+          <p:cNvSpPr/>
+          <p:nvPr/>
+        </p:nvSpPr>
+        <p:spPr>
+          <a:xfrm>
+            <a:off x="822960" y="1783080"/>
+            <a:ext cx="640080" cy="640080"/>
+          </a:xfrm>
+          <a:prstGeom prst="ellipse">
+            <a:avLst/>
+          </a:prstGeom>
+          <a:solidFill>
+            <a:srgbClr val="1E2761"/>
+          </a:solidFill>
+          <a:ln/>
+        </p:spPr>
+      </p:sp>
       <p:pic>
         <p:nvPicPr>
-          <p:cNvPr id="4" name="Image 0" descr="/sessions/busy-trusting-darwin/mnt/outputs/pptx_build/icons/lightbulb_E8702A.png">    </p:cNvPr>
+          <p:cNvPr id="6" name="Image 0" descr="/sessions/busy-trusting-darwin/mnt/outputs/pptx_build/icons/fileImage_FFFFFF.png">    </p:cNvPr>
           <p:cNvPicPr>
             <a:picLocks noChangeAspect="1"/>
           </p:cNvPicPr>
@@ -2495,8 +2645,8 @@
         </p:blipFill>
         <p:spPr>
           <a:xfrm>
-            <a:off x="614020" y="1802740"/>
-            <a:ext cx="372161" cy="372161"/>
+            <a:off x="906170" y="1866290"/>
+            <a:ext cx="473659" cy="473659"/>
           </a:xfrm>
           <a:prstGeom prst="rect">
             <a:avLst/>
@@ -2505,88 +2655,183 @@
       </p:pic>
       <p:sp>
         <p:nvSpPr>
-          <p:cNvPr id="5" name="Shape 2"/>
-          <p:cNvSpPr/>
-          <p:nvPr/>
-        </p:nvSpPr>
-        <p:spPr>
-          <a:xfrm>
-            <a:off x="1234440" y="1737360"/>
-            <a:ext cx="10424160" cy="777240"/>
-          </a:xfrm>
-          <a:prstGeom prst="roundRect">
-            <a:avLst>
-              <a:gd name="adj" fmla="val 9412"/>
-            </a:avLst>
+          <p:cNvPr id="7" name="Text 4"/>
+          <p:cNvSpPr/>
+          <p:nvPr/>
+        </p:nvSpPr>
+        <p:spPr>
+          <a:xfrm>
+            <a:off x="1645920" y="1892808"/>
+            <a:ext cx="4023360" cy="457200"/>
+          </a:xfrm>
+          <a:prstGeom prst="rect">
+            <a:avLst/>
+          </a:prstGeom>
+          <a:noFill/>
+          <a:ln/>
+        </p:spPr>
+        <p:txBody>
+          <a:bodyPr wrap="square" lIns="0" tIns="0" rIns="0" bIns="0" rtlCol="0" anchor="ctr"/>
+          <a:lstStyle/>
+          <a:p>
+            <a:pPr indent="0" marL="0">
+              <a:buNone/>
+            </a:pPr>
+            <a:r>
+              <a:rPr lang="en-US" sz="1500" b="1" dirty="0">
+                <a:solidFill>
+                  <a:srgbClr val="1E2761"/>
+                </a:solidFill>
+                <a:latin typeface="Calibri" pitchFamily="34" charset="0"/>
+                <a:ea typeface="Calibri" pitchFamily="34" charset="-122"/>
+                <a:cs typeface="Calibri" pitchFamily="34" charset="-120"/>
+              </a:rPr>
+              <a:t>OCR — fallback Nanonets</a:t>
+            </a:r>
+            <a:endParaRPr lang="en-US" sz="1500" dirty="0"/>
+          </a:p>
+        </p:txBody>
+      </p:sp>
+      <p:sp>
+        <p:nvSpPr>
+          <p:cNvPr id="8" name="Text 5"/>
+          <p:cNvSpPr/>
+          <p:nvPr/>
+        </p:nvSpPr>
+        <p:spPr>
+          <a:xfrm>
+            <a:off x="822960" y="2651760"/>
+            <a:ext cx="4800600" cy="548640"/>
+          </a:xfrm>
+          <a:prstGeom prst="rect">
+            <a:avLst/>
+          </a:prstGeom>
+          <a:noFill/>
+          <a:ln/>
+        </p:spPr>
+        <p:txBody>
+          <a:bodyPr wrap="square" lIns="0" tIns="0" rIns="0" bIns="0" rtlCol="0" anchor="ctr"/>
+          <a:lstStyle/>
+          <a:p>
+            <a:pPr indent="0" marL="0">
+              <a:buNone/>
+            </a:pPr>
+            <a:r>
+              <a:rPr lang="en-US" sz="1150" dirty="0">
+                <a:solidFill>
+                  <a:srgbClr val="1B1B2F"/>
+                </a:solidFill>
+                <a:latin typeface="Calibri" pitchFamily="34" charset="0"/>
+                <a:ea typeface="Calibri" pitchFamily="34" charset="-122"/>
+                <a:cs typeface="Calibri" pitchFamily="34" charset="-120"/>
+              </a:rPr>
+              <a:t>Fallback automatique quand un PDF n’a pas de couche de texte (rapport scanné).</a:t>
+            </a:r>
+            <a:endParaRPr lang="en-US" sz="1150" dirty="0"/>
+          </a:p>
+        </p:txBody>
+      </p:sp>
+      <p:sp>
+        <p:nvSpPr>
+          <p:cNvPr id="9" name="Text 6"/>
+          <p:cNvSpPr/>
+          <p:nvPr/>
+        </p:nvSpPr>
+        <p:spPr>
+          <a:xfrm>
+            <a:off x="914400" y="3383280"/>
+            <a:ext cx="1645920" cy="640080"/>
+          </a:xfrm>
+          <a:prstGeom prst="rect">
+            <a:avLst/>
+          </a:prstGeom>
+          <a:noFill/>
+          <a:ln/>
+        </p:spPr>
+        <p:txBody>
+          <a:bodyPr wrap="square" lIns="0" tIns="0" rIns="0" bIns="0" rtlCol="0" anchor="ctr"/>
+          <a:lstStyle/>
+          <a:p>
+            <a:pPr algn="ctr" indent="0" marL="0">
+              <a:buNone/>
+            </a:pPr>
+            <a:r>
+              <a:rPr lang="en-US" sz="3000" b="1" dirty="0">
+                <a:solidFill>
+                  <a:srgbClr val="6B7280"/>
+                </a:solidFill>
+                <a:latin typeface="Cambria" pitchFamily="34" charset="0"/>
+                <a:ea typeface="Cambria" pitchFamily="34" charset="-122"/>
+                <a:cs typeface="Cambria" pitchFamily="34" charset="-120"/>
+              </a:rPr>
+              <a:t>0,00</a:t>
+            </a:r>
+            <a:endParaRPr lang="en-US" sz="3000" dirty="0"/>
+          </a:p>
+        </p:txBody>
+      </p:sp>
+      <p:sp>
+        <p:nvSpPr>
+          <p:cNvPr id="10" name="Text 7"/>
+          <p:cNvSpPr/>
+          <p:nvPr/>
+        </p:nvSpPr>
+        <p:spPr>
+          <a:xfrm>
+            <a:off x="914400" y="3931920"/>
+            <a:ext cx="1645920" cy="320040"/>
+          </a:xfrm>
+          <a:prstGeom prst="rect">
+            <a:avLst/>
+          </a:prstGeom>
+          <a:noFill/>
+          <a:ln/>
+        </p:spPr>
+        <p:txBody>
+          <a:bodyPr wrap="square" lIns="0" tIns="0" rIns="0" bIns="0" rtlCol="0" anchor="ctr"/>
+          <a:lstStyle/>
+          <a:p>
+            <a:pPr algn="ctr" indent="0" marL="0">
+              <a:buNone/>
+            </a:pPr>
+            <a:r>
+              <a:rPr lang="en-US" sz="1000" dirty="0">
+                <a:solidFill>
+                  <a:srgbClr val="6B7280"/>
+                </a:solidFill>
+                <a:latin typeface="Calibri" pitchFamily="34" charset="0"/>
+                <a:ea typeface="Calibri" pitchFamily="34" charset="-122"/>
+                <a:cs typeface="Calibri" pitchFamily="34" charset="-120"/>
+              </a:rPr>
+              <a:t>avant</a:t>
+            </a:r>
+            <a:endParaRPr lang="en-US" sz="1000" dirty="0"/>
+          </a:p>
+        </p:txBody>
+      </p:sp>
+      <p:sp>
+        <p:nvSpPr>
+          <p:cNvPr id="11" name="Shape 8"/>
+          <p:cNvSpPr/>
+          <p:nvPr/>
+        </p:nvSpPr>
+        <p:spPr>
+          <a:xfrm>
+            <a:off x="2697480" y="3566160"/>
+            <a:ext cx="457200" cy="457200"/>
+          </a:xfrm>
+          <a:prstGeom prst="ellipse">
+            <a:avLst/>
           </a:prstGeom>
           <a:solidFill>
-            <a:srgbClr val="F9FAFB"/>
-          </a:solidFill>
-          <a:ln/>
-        </p:spPr>
-      </p:sp>
-      <p:sp>
-        <p:nvSpPr>
-          <p:cNvPr id="6" name="Text 3"/>
-          <p:cNvSpPr/>
-          <p:nvPr/>
-        </p:nvSpPr>
-        <p:spPr>
-          <a:xfrm>
-            <a:off x="1463040" y="1737360"/>
-            <a:ext cx="9966960" cy="777240"/>
-          </a:xfrm>
-          <a:prstGeom prst="rect">
-            <a:avLst/>
-          </a:prstGeom>
-          <a:noFill/>
-          <a:ln/>
-        </p:spPr>
-        <p:txBody>
-          <a:bodyPr wrap="square" lIns="0" tIns="0" rIns="0" bIns="0" rtlCol="0" anchor="ctr"/>
-          <a:lstStyle/>
-          <a:p>
-            <a:pPr indent="0" marL="0">
-              <a:buNone/>
-            </a:pPr>
-            <a:r>
-              <a:rPr lang="en-US" sz="1300" dirty="0">
-                <a:solidFill>
-                  <a:srgbClr val="1B1B2F"/>
-                </a:solidFill>
-                <a:latin typeface="Calibri" pitchFamily="34" charset="0"/>
-                <a:ea typeface="Calibri" pitchFamily="34" charset="-122"/>
-                <a:cs typeface="Calibri" pitchFamily="34" charset="-120"/>
-              </a:rPr>
-              <a:t>Échantillon volontairement restreint (13 questions) — à élargir pour des scores statistiquement robustes</a:t>
-            </a:r>
-            <a:endParaRPr lang="en-US" sz="1300" dirty="0"/>
-          </a:p>
-        </p:txBody>
-      </p:sp>
-      <p:sp>
-        <p:nvSpPr>
-          <p:cNvPr id="7" name="Shape 4"/>
-          <p:cNvSpPr/>
-          <p:nvPr/>
-        </p:nvSpPr>
-        <p:spPr>
-          <a:xfrm>
-            <a:off x="548640" y="2697480"/>
-            <a:ext cx="502920" cy="502920"/>
-          </a:xfrm>
-          <a:prstGeom prst="ellipse">
-            <a:avLst/>
-          </a:prstGeom>
-          <a:solidFill>
-            <a:srgbClr val="F4F6FC"/>
+            <a:srgbClr val="FFFFFF"/>
           </a:solidFill>
           <a:ln/>
         </p:spPr>
       </p:sp>
       <p:pic>
         <p:nvPicPr>
-          <p:cNvPr id="8" name="Image 1" descr="/sessions/busy-trusting-darwin/mnt/outputs/pptx_build/icons/lightbulb_E8702A.png">    </p:cNvPr>
+          <p:cNvPr id="12" name="Image 1" descr="/sessions/busy-trusting-darwin/mnt/outputs/pptx_build/icons/arrowRight_E8702A.png">    </p:cNvPr>
           <p:cNvPicPr>
             <a:picLocks noChangeAspect="1"/>
           </p:cNvPicPr>
@@ -2600,8 +2845,8 @@
         </p:blipFill>
         <p:spPr>
           <a:xfrm>
-            <a:off x="614020" y="2762860"/>
-            <a:ext cx="372161" cy="372161"/>
+            <a:off x="2756916" y="3625596"/>
+            <a:ext cx="338328" cy="338328"/>
           </a:xfrm>
           <a:prstGeom prst="rect">
             <a:avLst/>
@@ -2610,78 +2855,175 @@
       </p:pic>
       <p:sp>
         <p:nvSpPr>
-          <p:cNvPr id="9" name="Shape 5"/>
-          <p:cNvSpPr/>
-          <p:nvPr/>
-        </p:nvSpPr>
-        <p:spPr>
-          <a:xfrm>
-            <a:off x="1234440" y="2697480"/>
-            <a:ext cx="10424160" cy="777240"/>
+          <p:cNvPr id="13" name="Text 9"/>
+          <p:cNvSpPr/>
+          <p:nvPr/>
+        </p:nvSpPr>
+        <p:spPr>
+          <a:xfrm>
+            <a:off x="3291840" y="3383280"/>
+            <a:ext cx="1737360" cy="640080"/>
+          </a:xfrm>
+          <a:prstGeom prst="rect">
+            <a:avLst/>
+          </a:prstGeom>
+          <a:noFill/>
+          <a:ln/>
+        </p:spPr>
+        <p:txBody>
+          <a:bodyPr wrap="square" lIns="0" tIns="0" rIns="0" bIns="0" rtlCol="0" anchor="ctr"/>
+          <a:lstStyle/>
+          <a:p>
+            <a:pPr algn="ctr" indent="0" marL="0">
+              <a:buNone/>
+            </a:pPr>
+            <a:r>
+              <a:rPr lang="en-US" sz="3000" b="1" dirty="0">
+                <a:solidFill>
+                  <a:srgbClr val="E8702A"/>
+                </a:solidFill>
+                <a:latin typeface="Cambria" pitchFamily="34" charset="0"/>
+                <a:ea typeface="Cambria" pitchFamily="34" charset="-122"/>
+                <a:cs typeface="Cambria" pitchFamily="34" charset="-120"/>
+              </a:rPr>
+              <a:t>0,9757</a:t>
+            </a:r>
+            <a:endParaRPr lang="en-US" sz="3000" dirty="0"/>
+          </a:p>
+        </p:txBody>
+      </p:sp>
+      <p:sp>
+        <p:nvSpPr>
+          <p:cNvPr id="14" name="Text 10"/>
+          <p:cNvSpPr/>
+          <p:nvPr/>
+        </p:nvSpPr>
+        <p:spPr>
+          <a:xfrm>
+            <a:off x="3291840" y="3931920"/>
+            <a:ext cx="1737360" cy="320040"/>
+          </a:xfrm>
+          <a:prstGeom prst="rect">
+            <a:avLst/>
+          </a:prstGeom>
+          <a:noFill/>
+          <a:ln/>
+        </p:spPr>
+        <p:txBody>
+          <a:bodyPr wrap="square" lIns="0" tIns="0" rIns="0" bIns="0" rtlCol="0" anchor="ctr"/>
+          <a:lstStyle/>
+          <a:p>
+            <a:pPr algn="ctr" indent="0" marL="0">
+              <a:buNone/>
+            </a:pPr>
+            <a:r>
+              <a:rPr lang="en-US" sz="1000" dirty="0">
+                <a:solidFill>
+                  <a:srgbClr val="6B7280"/>
+                </a:solidFill>
+                <a:latin typeface="Calibri" pitchFamily="34" charset="0"/>
+                <a:ea typeface="Calibri" pitchFamily="34" charset="-122"/>
+                <a:cs typeface="Calibri" pitchFamily="34" charset="-120"/>
+              </a:rPr>
+              <a:t>après (similarité)</a:t>
+            </a:r>
+            <a:endParaRPr lang="en-US" sz="1000" dirty="0"/>
+          </a:p>
+        </p:txBody>
+      </p:sp>
+      <p:sp>
+        <p:nvSpPr>
+          <p:cNvPr id="15" name="Text 11"/>
+          <p:cNvSpPr/>
+          <p:nvPr/>
+        </p:nvSpPr>
+        <p:spPr>
+          <a:xfrm>
+            <a:off x="822960" y="4480560"/>
+            <a:ext cx="4800600" cy="822960"/>
+          </a:xfrm>
+          <a:prstGeom prst="rect">
+            <a:avLst/>
+          </a:prstGeom>
+          <a:noFill/>
+          <a:ln/>
+        </p:spPr>
+        <p:txBody>
+          <a:bodyPr wrap="square" lIns="0" tIns="0" rIns="0" bIns="0" rtlCol="0" anchor="ctr"/>
+          <a:lstStyle/>
+          <a:p>
+            <a:pPr indent="0" marL="0">
+              <a:buNone/>
+            </a:pPr>
+            <a:r>
+              <a:rPr lang="en-US" sz="1100" dirty="0">
+                <a:solidFill>
+                  <a:srgbClr val="1B1B2F"/>
+                </a:solidFill>
+                <a:latin typeface="Calibri" pitchFamily="34" charset="0"/>
+                <a:ea typeface="Calibri" pitchFamily="34" charset="-122"/>
+                <a:cs typeface="Calibri" pitchFamily="34" charset="-120"/>
+              </a:rPr>
+              <a:t>413 caractères restitués sur un document de test synthétique reproductible (evaluate_ocr.py) — amélioration de +0,98.</a:t>
+            </a:r>
+            <a:endParaRPr lang="en-US" sz="1100" dirty="0"/>
+          </a:p>
+        </p:txBody>
+      </p:sp>
+      <p:sp>
+        <p:nvSpPr>
+          <p:cNvPr id="16" name="Text 12"/>
+          <p:cNvSpPr/>
+          <p:nvPr/>
+        </p:nvSpPr>
+        <p:spPr>
+          <a:xfrm>
+            <a:off x="822960" y="5349240"/>
+            <a:ext cx="4800600" cy="457200"/>
+          </a:xfrm>
+          <a:prstGeom prst="rect">
+            <a:avLst/>
+          </a:prstGeom>
+          <a:noFill/>
+          <a:ln/>
+        </p:spPr>
+        <p:txBody>
+          <a:bodyPr wrap="square" lIns="0" tIns="0" rIns="0" bIns="0" rtlCol="0" anchor="ctr"/>
+          <a:lstStyle/>
+          <a:p>
+            <a:pPr indent="0" marL="0">
+              <a:buNone/>
+            </a:pPr>
+            <a:r>
+              <a:rPr lang="en-US" sz="1050" i="1" dirty="0">
+                <a:solidFill>
+                  <a:srgbClr val="6B7280"/>
+                </a:solidFill>
+                <a:latin typeface="Calibri" pitchFamily="34" charset="0"/>
+                <a:ea typeface="Calibri" pitchFamily="34" charset="-122"/>
+                <a:cs typeface="Calibri" pitchFamily="34" charset="-120"/>
+              </a:rPr>
+              <a:t>Sans clé API : désactivation propre, aucun crash.</a:t>
+            </a:r>
+            <a:endParaRPr lang="en-US" sz="1050" dirty="0"/>
+          </a:p>
+        </p:txBody>
+      </p:sp>
+      <p:sp>
+        <p:nvSpPr>
+          <p:cNvPr id="17" name="Shape 13"/>
+          <p:cNvSpPr/>
+          <p:nvPr/>
+        </p:nvSpPr>
+        <p:spPr>
+          <a:xfrm>
+            <a:off x="6291072" y="1508760"/>
+            <a:ext cx="5349240" cy="4480560"/>
           </a:xfrm>
           <a:prstGeom prst="roundRect">
             <a:avLst>
-              <a:gd name="adj" fmla="val 9412"/>
+              <a:gd name="adj" fmla="val 2041"/>
             </a:avLst>
-          </a:prstGeom>
-          <a:solidFill>
-            <a:srgbClr val="F9FAFB"/>
-          </a:solidFill>
-          <a:ln/>
-        </p:spPr>
-      </p:sp>
-      <p:sp>
-        <p:nvSpPr>
-          <p:cNvPr id="10" name="Text 6"/>
-          <p:cNvSpPr/>
-          <p:nvPr/>
-        </p:nvSpPr>
-        <p:spPr>
-          <a:xfrm>
-            <a:off x="1463040" y="2697480"/>
-            <a:ext cx="9966960" cy="777240"/>
-          </a:xfrm>
-          <a:prstGeom prst="rect">
-            <a:avLst/>
-          </a:prstGeom>
-          <a:noFill/>
-          <a:ln/>
-        </p:spPr>
-        <p:txBody>
-          <a:bodyPr wrap="square" lIns="0" tIns="0" rIns="0" bIns="0" rtlCol="0" anchor="ctr"/>
-          <a:lstStyle/>
-          <a:p>
-            <a:pPr indent="0" marL="0">
-              <a:buNone/>
-            </a:pPr>
-            <a:r>
-              <a:rPr lang="en-US" sz="1300" dirty="0">
-                <a:solidFill>
-                  <a:srgbClr val="1B1B2F"/>
-                </a:solidFill>
-                <a:latin typeface="Calibri" pitchFamily="34" charset="0"/>
-                <a:ea typeface="Calibri" pitchFamily="34" charset="-122"/>
-                <a:cs typeface="Calibri" pitchFamily="34" charset="-120"/>
-              </a:rPr>
-              <a:t>Granularité des données NBA limitée à la saison (pas de match par match, pas de domicile/extérieur)</a:t>
-            </a:r>
-            <a:endParaRPr lang="en-US" sz="1300" dirty="0"/>
-          </a:p>
-        </p:txBody>
-      </p:sp>
-      <p:sp>
-        <p:nvSpPr>
-          <p:cNvPr id="11" name="Shape 7"/>
-          <p:cNvSpPr/>
-          <p:nvPr/>
-        </p:nvSpPr>
-        <p:spPr>
-          <a:xfrm>
-            <a:off x="548640" y="3657600"/>
-            <a:ext cx="502920" cy="502920"/>
-          </a:xfrm>
-          <a:prstGeom prst="ellipse">
-            <a:avLst/>
           </a:prstGeom>
           <a:solidFill>
             <a:srgbClr val="F4F6FC"/>
@@ -2689,9 +3031,29 @@
           <a:ln/>
         </p:spPr>
       </p:sp>
+      <p:sp>
+        <p:nvSpPr>
+          <p:cNvPr id="18" name="Shape 14"/>
+          <p:cNvSpPr/>
+          <p:nvPr/>
+        </p:nvSpPr>
+        <p:spPr>
+          <a:xfrm>
+            <a:off x="6565392" y="1783080"/>
+            <a:ext cx="640080" cy="640080"/>
+          </a:xfrm>
+          <a:prstGeom prst="ellipse">
+            <a:avLst/>
+          </a:prstGeom>
+          <a:solidFill>
+            <a:srgbClr val="1E2761"/>
+          </a:solidFill>
+          <a:ln/>
+        </p:spPr>
+      </p:sp>
       <p:pic>
         <p:nvPicPr>
-          <p:cNvPr id="12" name="Image 2" descr="/sessions/busy-trusting-darwin/mnt/outputs/pptx_build/icons/lightbulb_E8702A.png">    </p:cNvPr>
+          <p:cNvPr id="19" name="Image 2" descr="/sessions/busy-trusting-darwin/mnt/outputs/pptx_build/icons/chartPie_FFFFFF.png">    </p:cNvPr>
           <p:cNvPicPr>
             <a:picLocks noChangeAspect="1"/>
           </p:cNvPicPr>
@@ -2705,8 +3067,8 @@
         </p:blipFill>
         <p:spPr>
           <a:xfrm>
-            <a:off x="614020" y="3722980"/>
-            <a:ext cx="372161" cy="372161"/>
+            <a:off x="6648602" y="1866290"/>
+            <a:ext cx="473659" cy="473659"/>
           </a:xfrm>
           <a:prstGeom prst="rect">
             <a:avLst/>
@@ -2715,36 +3077,114 @@
       </p:pic>
       <p:sp>
         <p:nvSpPr>
-          <p:cNvPr id="13" name="Shape 8"/>
-          <p:cNvSpPr/>
-          <p:nvPr/>
-        </p:nvSpPr>
-        <p:spPr>
-          <a:xfrm>
-            <a:off x="1234440" y="3657600"/>
-            <a:ext cx="10424160" cy="777240"/>
+          <p:cNvPr id="20" name="Text 15"/>
+          <p:cNvSpPr/>
+          <p:nvPr/>
+        </p:nvSpPr>
+        <p:spPr>
+          <a:xfrm>
+            <a:off x="7388352" y="1892808"/>
+            <a:ext cx="4023360" cy="457200"/>
+          </a:xfrm>
+          <a:prstGeom prst="rect">
+            <a:avLst/>
+          </a:prstGeom>
+          <a:noFill/>
+          <a:ln/>
+        </p:spPr>
+        <p:txBody>
+          <a:bodyPr wrap="square" lIns="0" tIns="0" rIns="0" bIns="0" rtlCol="0" anchor="ctr"/>
+          <a:lstStyle/>
+          <a:p>
+            <a:pPr indent="0" marL="0">
+              <a:buNone/>
+            </a:pPr>
+            <a:r>
+              <a:rPr lang="en-US" sz="1400" b="1" dirty="0">
+                <a:solidFill>
+                  <a:srgbClr val="1E2761"/>
+                </a:solidFill>
+                <a:latin typeface="Calibri" pitchFamily="34" charset="0"/>
+                <a:ea typeface="Calibri" pitchFamily="34" charset="-122"/>
+                <a:cs typeface="Calibri" pitchFamily="34" charset="-120"/>
+              </a:rPr>
+              <a:t>PlotTool — graphiques dynamiques</a:t>
+            </a:r>
+            <a:endParaRPr lang="en-US" sz="1400" dirty="0"/>
+          </a:p>
+        </p:txBody>
+      </p:sp>
+      <p:sp>
+        <p:nvSpPr>
+          <p:cNvPr id="21" name="Text 16"/>
+          <p:cNvSpPr/>
+          <p:nvPr/>
+        </p:nvSpPr>
+        <p:spPr>
+          <a:xfrm>
+            <a:off x="6565392" y="2651760"/>
+            <a:ext cx="4800600" cy="731520"/>
+          </a:xfrm>
+          <a:prstGeom prst="rect">
+            <a:avLst/>
+          </a:prstGeom>
+          <a:noFill/>
+          <a:ln/>
+        </p:spPr>
+        <p:txBody>
+          <a:bodyPr wrap="square" lIns="0" tIns="0" rIns="0" bIns="0" rtlCol="0" anchor="ctr"/>
+          <a:lstStyle/>
+          <a:p>
+            <a:pPr indent="0" marL="0">
+              <a:buNone/>
+            </a:pPr>
+            <a:r>
+              <a:rPr lang="en-US" sz="1150" dirty="0">
+                <a:solidFill>
+                  <a:srgbClr val="1B1B2F"/>
+                </a:solidFill>
+                <a:latin typeface="Calibri" pitchFamily="34" charset="0"/>
+                <a:ea typeface="Calibri" pitchFamily="34" charset="-122"/>
+                <a:cs typeface="Calibri" pitchFamily="34" charset="-120"/>
+              </a:rPr>
+              <a:t>Le chatbot produit un graphique (barres / courbe / camembert) sur demande explicite (« montre un graphique de… »).</a:t>
+            </a:r>
+            <a:endParaRPr lang="en-US" sz="1150" dirty="0"/>
+          </a:p>
+        </p:txBody>
+      </p:sp>
+      <p:sp>
+        <p:nvSpPr>
+          <p:cNvPr id="22" name="Shape 17"/>
+          <p:cNvSpPr/>
+          <p:nvPr/>
+        </p:nvSpPr>
+        <p:spPr>
+          <a:xfrm>
+            <a:off x="6565392" y="3566160"/>
+            <a:ext cx="4800600" cy="1371600"/>
           </a:xfrm>
           <a:prstGeom prst="roundRect">
             <a:avLst>
-              <a:gd name="adj" fmla="val 9412"/>
+              <a:gd name="adj" fmla="val 5333"/>
             </a:avLst>
           </a:prstGeom>
           <a:solidFill>
-            <a:srgbClr val="F9FAFB"/>
+            <a:srgbClr val="1E2761"/>
           </a:solidFill>
           <a:ln/>
         </p:spPr>
       </p:sp>
       <p:sp>
         <p:nvSpPr>
-          <p:cNvPr id="14" name="Text 9"/>
-          <p:cNvSpPr/>
-          <p:nvPr/>
-        </p:nvSpPr>
-        <p:spPr>
-          <a:xfrm>
-            <a:off x="1463040" y="3657600"/>
-            <a:ext cx="9966960" cy="777240"/>
+          <p:cNvPr id="23" name="Text 18"/>
+          <p:cNvSpPr/>
+          <p:nvPr/>
+        </p:nvSpPr>
+        <p:spPr>
+          <a:xfrm>
+            <a:off x="6793992" y="3566160"/>
+            <a:ext cx="4343400" cy="1371600"/>
           </a:xfrm>
           <a:prstGeom prst="rect">
             <a:avLst/>
@@ -2760,96 +3200,30 @@
               <a:buNone/>
             </a:pPr>
             <a:r>
-              <a:rPr lang="en-US" sz="1300" dirty="0">
-                <a:solidFill>
-                  <a:srgbClr val="1B1B2F"/>
-                </a:solidFill>
-                <a:latin typeface="Calibri" pitchFamily="34" charset="0"/>
-                <a:ea typeface="Calibri" pitchFamily="34" charset="-122"/>
-                <a:cs typeface="Calibri" pitchFamily="34" charset="-120"/>
-              </a:rPr>
-              <a:t>Ground truths à faire valider par un référent métier (Sarah)</a:t>
-            </a:r>
-            <a:endParaRPr lang="en-US" sz="1300" dirty="0"/>
-          </a:p>
-        </p:txBody>
-      </p:sp>
-      <p:sp>
-        <p:nvSpPr>
-          <p:cNvPr id="15" name="Shape 10"/>
-          <p:cNvSpPr/>
-          <p:nvPr/>
-        </p:nvSpPr>
-        <p:spPr>
-          <a:xfrm>
-            <a:off x="548640" y="4617720"/>
-            <a:ext cx="502920" cy="502920"/>
-          </a:xfrm>
-          <a:prstGeom prst="ellipse">
-            <a:avLst/>
-          </a:prstGeom>
-          <a:solidFill>
-            <a:srgbClr val="F4F6FC"/>
-          </a:solidFill>
-          <a:ln/>
-        </p:spPr>
-      </p:sp>
-      <p:pic>
-        <p:nvPicPr>
-          <p:cNvPr id="16" name="Image 3" descr="/sessions/busy-trusting-darwin/mnt/outputs/pptx_build/icons/lightbulb_E8702A.png">    </p:cNvPr>
-          <p:cNvPicPr>
-            <a:picLocks noChangeAspect="1"/>
-          </p:cNvPicPr>
-          <p:nvPr/>
-        </p:nvPicPr>
-        <p:blipFill>
-          <a:blip r:embed="rId4"/>
-          <a:stretch>
-            <a:fillRect/>
-          </a:stretch>
-        </p:blipFill>
-        <p:spPr>
-          <a:xfrm>
-            <a:off x="614020" y="4683100"/>
-            <a:ext cx="372161" cy="372161"/>
-          </a:xfrm>
-          <a:prstGeom prst="rect">
-            <a:avLst/>
-          </a:prstGeom>
-        </p:spPr>
-      </p:pic>
-      <p:sp>
-        <p:nvSpPr>
-          <p:cNvPr id="17" name="Shape 11"/>
-          <p:cNvSpPr/>
-          <p:nvPr/>
-        </p:nvSpPr>
-        <p:spPr>
-          <a:xfrm>
-            <a:off x="1234440" y="4617720"/>
-            <a:ext cx="10424160" cy="777240"/>
-          </a:xfrm>
-          <a:prstGeom prst="roundRect">
-            <a:avLst>
-              <a:gd name="adj" fmla="val 9412"/>
-            </a:avLst>
-          </a:prstGeom>
-          <a:solidFill>
-            <a:srgbClr val="F9FAFB"/>
-          </a:solidFill>
-          <a:ln/>
-        </p:spPr>
-      </p:sp>
-      <p:sp>
-        <p:nvSpPr>
-          <p:cNvPr id="18" name="Text 12"/>
-          <p:cNvSpPr/>
-          <p:nvPr/>
-        </p:nvSpPr>
-        <p:spPr>
-          <a:xfrm>
-            <a:off x="1463040" y="4617720"/>
-            <a:ext cx="9966960" cy="777240"/>
+              <a:rPr lang="en-US" sz="1200" b="1" dirty="0">
+                <a:solidFill>
+                  <a:srgbClr val="FFFFFF"/>
+                </a:solidFill>
+                <a:latin typeface="Calibri" pitchFamily="34" charset="0"/>
+                <a:ea typeface="Calibri" pitchFamily="34" charset="-122"/>
+                <a:cs typeface="Calibri" pitchFamily="34" charset="-120"/>
+              </a:rPr>
+              <a:t>Garde-fou : le PlotTool ne réutilise QUE les données déjà validées par le SQL Tool — il ne peut pas inventer une valeur.</a:t>
+            </a:r>
+            <a:endParaRPr lang="en-US" sz="1200" dirty="0"/>
+          </a:p>
+        </p:txBody>
+      </p:sp>
+      <p:sp>
+        <p:nvSpPr>
+          <p:cNvPr id="24" name="Text 19"/>
+          <p:cNvSpPr/>
+          <p:nvPr/>
+        </p:nvSpPr>
+        <p:spPr>
+          <a:xfrm>
+            <a:off x="6565392" y="5166360"/>
+            <a:ext cx="4800600" cy="640080"/>
           </a:xfrm>
           <a:prstGeom prst="rect">
             <a:avLst/>
@@ -2865,46 +3239,7 @@
               <a:buNone/>
             </a:pPr>
             <a:r>
-              <a:rPr lang="en-US" sz="1300" dirty="0">
-                <a:solidFill>
-                  <a:srgbClr val="1B1B2F"/>
-                </a:solidFill>
-                <a:latin typeface="Calibri" pitchFamily="34" charset="0"/>
-                <a:ea typeface="Calibri" pitchFamily="34" charset="-122"/>
-                <a:cs typeface="Calibri" pitchFamily="34" charset="-120"/>
-              </a:rPr>
-              <a:t>Coût / latence non mesurés — à ajouter pour un usage en production</a:t>
-            </a:r>
-            <a:endParaRPr lang="en-US" sz="1300" dirty="0"/>
-          </a:p>
-        </p:txBody>
-      </p:sp>
-      <p:sp>
-        <p:nvSpPr>
-          <p:cNvPr id="19" name="Text 13"/>
-          <p:cNvSpPr/>
-          <p:nvPr/>
-        </p:nvSpPr>
-        <p:spPr>
-          <a:xfrm>
-            <a:off x="548640" y="5715000"/>
-            <a:ext cx="11091672" cy="548640"/>
-          </a:xfrm>
-          <a:prstGeom prst="rect">
-            <a:avLst/>
-          </a:prstGeom>
-          <a:noFill/>
-          <a:ln/>
-        </p:spPr>
-        <p:txBody>
-          <a:bodyPr wrap="square" lIns="0" tIns="0" rIns="0" bIns="0" rtlCol="0" anchor="ctr"/>
-          <a:lstStyle/>
-          <a:p>
-            <a:pPr indent="0" marL="0">
-              <a:buNone/>
-            </a:pPr>
-            <a:r>
-              <a:rPr lang="en-US" sz="1200" i="1" dirty="0">
+              <a:rPr lang="en-US" sz="1050" i="1" dirty="0">
                 <a:solidFill>
                   <a:srgbClr val="6B7280"/>
                 </a:solidFill>
@@ -2912,15 +3247,15 @@
                 <a:ea typeface="Calibri" pitchFamily="34" charset="-122"/>
                 <a:cs typeface="Calibri" pitchFamily="34" charset="-120"/>
               </a:rPr>
-              <a:t>Je préfère assumer ces limites explicitement plutôt que de présenter un score parfait qui ne résisterait pas à un examen approfondi.</a:t>
-            </a:r>
-            <a:endParaRPr lang="en-US" sz="1200" dirty="0"/>
-          </a:p>
-        </p:txBody>
-      </p:sp>
-      <p:sp>
-        <p:nvSpPr>
-          <p:cNvPr id="20" name="Text 14"/>
+              <a:t>Seul le type de graphique est choisi automatiquement (heuristique, sans appel LLM supplémentaire).</a:t>
+            </a:r>
+            <a:endParaRPr lang="en-US" sz="1050" dirty="0"/>
+          </a:p>
+        </p:txBody>
+      </p:sp>
+      <p:sp>
+        <p:nvSpPr>
+          <p:cNvPr id="25" name="Text 20"/>
           <p:cNvSpPr/>
           <p:nvPr/>
         </p:nvSpPr>
@@ -2959,7 +3294,7 @@
       </p:sp>
       <p:sp>
         <p:nvSpPr>
-          <p:cNvPr id="21" name="Text 15"/>
+          <p:cNvPr id="26" name="Text 21"/>
           <p:cNvSpPr/>
           <p:nvPr/>
         </p:nvSpPr>
@@ -3007,6 +3342,614 @@
 <file path=ppt/slides/slide11.xml><?xml version="1.0" encoding="utf-8"?>
 <p:sld xmlns:a="http://schemas.openxmlformats.org/drawingml/2006/main" xmlns:r="http://schemas.openxmlformats.org/officeDocument/2006/relationships" xmlns:p="http://schemas.openxmlformats.org/presentationml/2006/main">
   <p:cSld name="Slide 11">
+    <p:bg>
+      <p:bgPr>
+        <a:solidFill>
+          <a:srgbClr val="FFFFFF"/>
+        </a:solidFill>
+      </p:bgPr>
+    </p:bg>
+    <p:spTree>
+      <p:nvGrpSpPr>
+        <p:cNvPr id="1" name=""/>
+        <p:cNvGrpSpPr/>
+        <p:nvPr/>
+      </p:nvGrpSpPr>
+      <p:grpSpPr>
+        <a:xfrm>
+          <a:off x="0" y="0"/>
+          <a:ext cx="0" cy="0"/>
+          <a:chOff x="0" y="0"/>
+          <a:chExt cx="0" cy="0"/>
+        </a:xfrm>
+      </p:grpSpPr>
+      <p:sp>
+        <p:nvSpPr>
+          <p:cNvPr id="2" name="Text 0"/>
+          <p:cNvSpPr/>
+          <p:nvPr/>
+        </p:nvSpPr>
+        <p:spPr>
+          <a:xfrm>
+            <a:off x="548640" y="411480"/>
+            <a:ext cx="11064240" cy="731520"/>
+          </a:xfrm>
+          <a:prstGeom prst="rect">
+            <a:avLst/>
+          </a:prstGeom>
+          <a:noFill/>
+          <a:ln/>
+        </p:spPr>
+        <p:txBody>
+          <a:bodyPr wrap="square" lIns="0" tIns="0" rIns="0" bIns="0" rtlCol="0" anchor="ctr"/>
+          <a:lstStyle/>
+          <a:p>
+            <a:pPr algn="l" indent="0" marL="0">
+              <a:buNone/>
+            </a:pPr>
+            <a:r>
+              <a:rPr lang="en-US" sz="3200" b="1" dirty="0">
+                <a:solidFill>
+                  <a:srgbClr val="1E2761"/>
+                </a:solidFill>
+                <a:latin typeface="Cambria" pitchFamily="34" charset="0"/>
+                <a:ea typeface="Cambria" pitchFamily="34" charset="-122"/>
+                <a:cs typeface="Cambria" pitchFamily="34" charset="-120"/>
+              </a:rPr>
+              <a:t>Limites et pistes d’amélioration</a:t>
+            </a:r>
+            <a:endParaRPr lang="en-US" sz="3200" dirty="0"/>
+          </a:p>
+        </p:txBody>
+      </p:sp>
+      <p:sp>
+        <p:nvSpPr>
+          <p:cNvPr id="3" name="Shape 1"/>
+          <p:cNvSpPr/>
+          <p:nvPr/>
+        </p:nvSpPr>
+        <p:spPr>
+          <a:xfrm>
+            <a:off x="548640" y="1737360"/>
+            <a:ext cx="502920" cy="502920"/>
+          </a:xfrm>
+          <a:prstGeom prst="ellipse">
+            <a:avLst/>
+          </a:prstGeom>
+          <a:solidFill>
+            <a:srgbClr val="F4F6FC"/>
+          </a:solidFill>
+          <a:ln/>
+        </p:spPr>
+      </p:sp>
+      <p:pic>
+        <p:nvPicPr>
+          <p:cNvPr id="4" name="Image 0" descr="/sessions/busy-trusting-darwin/mnt/outputs/pptx_build/icons/lightbulb_E8702A.png">    </p:cNvPr>
+          <p:cNvPicPr>
+            <a:picLocks noChangeAspect="1"/>
+          </p:cNvPicPr>
+          <p:nvPr/>
+        </p:nvPicPr>
+        <p:blipFill>
+          <a:blip r:embed="rId1"/>
+          <a:stretch>
+            <a:fillRect/>
+          </a:stretch>
+        </p:blipFill>
+        <p:spPr>
+          <a:xfrm>
+            <a:off x="614020" y="1802740"/>
+            <a:ext cx="372161" cy="372161"/>
+          </a:xfrm>
+          <a:prstGeom prst="rect">
+            <a:avLst/>
+          </a:prstGeom>
+        </p:spPr>
+      </p:pic>
+      <p:sp>
+        <p:nvSpPr>
+          <p:cNvPr id="5" name="Shape 2"/>
+          <p:cNvSpPr/>
+          <p:nvPr/>
+        </p:nvSpPr>
+        <p:spPr>
+          <a:xfrm>
+            <a:off x="1234440" y="1737360"/>
+            <a:ext cx="10424160" cy="777240"/>
+          </a:xfrm>
+          <a:prstGeom prst="roundRect">
+            <a:avLst>
+              <a:gd name="adj" fmla="val 9412"/>
+            </a:avLst>
+          </a:prstGeom>
+          <a:solidFill>
+            <a:srgbClr val="F9FAFB"/>
+          </a:solidFill>
+          <a:ln/>
+        </p:spPr>
+      </p:sp>
+      <p:sp>
+        <p:nvSpPr>
+          <p:cNvPr id="6" name="Text 3"/>
+          <p:cNvSpPr/>
+          <p:nvPr/>
+        </p:nvSpPr>
+        <p:spPr>
+          <a:xfrm>
+            <a:off x="1463040" y="1737360"/>
+            <a:ext cx="9966960" cy="777240"/>
+          </a:xfrm>
+          <a:prstGeom prst="rect">
+            <a:avLst/>
+          </a:prstGeom>
+          <a:noFill/>
+          <a:ln/>
+        </p:spPr>
+        <p:txBody>
+          <a:bodyPr wrap="square" lIns="0" tIns="0" rIns="0" bIns="0" rtlCol="0" anchor="ctr"/>
+          <a:lstStyle/>
+          <a:p>
+            <a:pPr indent="0" marL="0">
+              <a:buNone/>
+            </a:pPr>
+            <a:r>
+              <a:rPr lang="en-US" sz="1300" dirty="0">
+                <a:solidFill>
+                  <a:srgbClr val="1B1B2F"/>
+                </a:solidFill>
+                <a:latin typeface="Calibri" pitchFamily="34" charset="0"/>
+                <a:ea typeface="Calibri" pitchFamily="34" charset="-122"/>
+                <a:cs typeface="Calibri" pitchFamily="34" charset="-120"/>
+              </a:rPr>
+              <a:t>Échantillon volontairement restreint (13 questions) — à élargir pour des scores statistiquement robustes</a:t>
+            </a:r>
+            <a:endParaRPr lang="en-US" sz="1300" dirty="0"/>
+          </a:p>
+        </p:txBody>
+      </p:sp>
+      <p:sp>
+        <p:nvSpPr>
+          <p:cNvPr id="7" name="Shape 4"/>
+          <p:cNvSpPr/>
+          <p:nvPr/>
+        </p:nvSpPr>
+        <p:spPr>
+          <a:xfrm>
+            <a:off x="548640" y="2697480"/>
+            <a:ext cx="502920" cy="502920"/>
+          </a:xfrm>
+          <a:prstGeom prst="ellipse">
+            <a:avLst/>
+          </a:prstGeom>
+          <a:solidFill>
+            <a:srgbClr val="F4F6FC"/>
+          </a:solidFill>
+          <a:ln/>
+        </p:spPr>
+      </p:sp>
+      <p:pic>
+        <p:nvPicPr>
+          <p:cNvPr id="8" name="Image 1" descr="/sessions/busy-trusting-darwin/mnt/outputs/pptx_build/icons/lightbulb_E8702A.png">    </p:cNvPr>
+          <p:cNvPicPr>
+            <a:picLocks noChangeAspect="1"/>
+          </p:cNvPicPr>
+          <p:nvPr/>
+        </p:nvPicPr>
+        <p:blipFill>
+          <a:blip r:embed="rId2"/>
+          <a:stretch>
+            <a:fillRect/>
+          </a:stretch>
+        </p:blipFill>
+        <p:spPr>
+          <a:xfrm>
+            <a:off x="614020" y="2762860"/>
+            <a:ext cx="372161" cy="372161"/>
+          </a:xfrm>
+          <a:prstGeom prst="rect">
+            <a:avLst/>
+          </a:prstGeom>
+        </p:spPr>
+      </p:pic>
+      <p:sp>
+        <p:nvSpPr>
+          <p:cNvPr id="9" name="Shape 5"/>
+          <p:cNvSpPr/>
+          <p:nvPr/>
+        </p:nvSpPr>
+        <p:spPr>
+          <a:xfrm>
+            <a:off x="1234440" y="2697480"/>
+            <a:ext cx="10424160" cy="777240"/>
+          </a:xfrm>
+          <a:prstGeom prst="roundRect">
+            <a:avLst>
+              <a:gd name="adj" fmla="val 9412"/>
+            </a:avLst>
+          </a:prstGeom>
+          <a:solidFill>
+            <a:srgbClr val="F9FAFB"/>
+          </a:solidFill>
+          <a:ln/>
+        </p:spPr>
+      </p:sp>
+      <p:sp>
+        <p:nvSpPr>
+          <p:cNvPr id="10" name="Text 6"/>
+          <p:cNvSpPr/>
+          <p:nvPr/>
+        </p:nvSpPr>
+        <p:spPr>
+          <a:xfrm>
+            <a:off x="1463040" y="2697480"/>
+            <a:ext cx="9966960" cy="777240"/>
+          </a:xfrm>
+          <a:prstGeom prst="rect">
+            <a:avLst/>
+          </a:prstGeom>
+          <a:noFill/>
+          <a:ln/>
+        </p:spPr>
+        <p:txBody>
+          <a:bodyPr wrap="square" lIns="0" tIns="0" rIns="0" bIns="0" rtlCol="0" anchor="ctr"/>
+          <a:lstStyle/>
+          <a:p>
+            <a:pPr indent="0" marL="0">
+              <a:buNone/>
+            </a:pPr>
+            <a:r>
+              <a:rPr lang="en-US" sz="1300" dirty="0">
+                <a:solidFill>
+                  <a:srgbClr val="1B1B2F"/>
+                </a:solidFill>
+                <a:latin typeface="Calibri" pitchFamily="34" charset="0"/>
+                <a:ea typeface="Calibri" pitchFamily="34" charset="-122"/>
+                <a:cs typeface="Calibri" pitchFamily="34" charset="-120"/>
+              </a:rPr>
+              <a:t>Granularité des données NBA limitée à la saison (pas de match par match, pas de domicile/extérieur)</a:t>
+            </a:r>
+            <a:endParaRPr lang="en-US" sz="1300" dirty="0"/>
+          </a:p>
+        </p:txBody>
+      </p:sp>
+      <p:sp>
+        <p:nvSpPr>
+          <p:cNvPr id="11" name="Shape 7"/>
+          <p:cNvSpPr/>
+          <p:nvPr/>
+        </p:nvSpPr>
+        <p:spPr>
+          <a:xfrm>
+            <a:off x="548640" y="3657600"/>
+            <a:ext cx="502920" cy="502920"/>
+          </a:xfrm>
+          <a:prstGeom prst="ellipse">
+            <a:avLst/>
+          </a:prstGeom>
+          <a:solidFill>
+            <a:srgbClr val="F4F6FC"/>
+          </a:solidFill>
+          <a:ln/>
+        </p:spPr>
+      </p:sp>
+      <p:pic>
+        <p:nvPicPr>
+          <p:cNvPr id="12" name="Image 2" descr="/sessions/busy-trusting-darwin/mnt/outputs/pptx_build/icons/lightbulb_E8702A.png">    </p:cNvPr>
+          <p:cNvPicPr>
+            <a:picLocks noChangeAspect="1"/>
+          </p:cNvPicPr>
+          <p:nvPr/>
+        </p:nvPicPr>
+        <p:blipFill>
+          <a:blip r:embed="rId3"/>
+          <a:stretch>
+            <a:fillRect/>
+          </a:stretch>
+        </p:blipFill>
+        <p:spPr>
+          <a:xfrm>
+            <a:off x="614020" y="3722980"/>
+            <a:ext cx="372161" cy="372161"/>
+          </a:xfrm>
+          <a:prstGeom prst="rect">
+            <a:avLst/>
+          </a:prstGeom>
+        </p:spPr>
+      </p:pic>
+      <p:sp>
+        <p:nvSpPr>
+          <p:cNvPr id="13" name="Shape 8"/>
+          <p:cNvSpPr/>
+          <p:nvPr/>
+        </p:nvSpPr>
+        <p:spPr>
+          <a:xfrm>
+            <a:off x="1234440" y="3657600"/>
+            <a:ext cx="10424160" cy="777240"/>
+          </a:xfrm>
+          <a:prstGeom prst="roundRect">
+            <a:avLst>
+              <a:gd name="adj" fmla="val 9412"/>
+            </a:avLst>
+          </a:prstGeom>
+          <a:solidFill>
+            <a:srgbClr val="F9FAFB"/>
+          </a:solidFill>
+          <a:ln/>
+        </p:spPr>
+      </p:sp>
+      <p:sp>
+        <p:nvSpPr>
+          <p:cNvPr id="14" name="Text 9"/>
+          <p:cNvSpPr/>
+          <p:nvPr/>
+        </p:nvSpPr>
+        <p:spPr>
+          <a:xfrm>
+            <a:off x="1463040" y="3657600"/>
+            <a:ext cx="9966960" cy="777240"/>
+          </a:xfrm>
+          <a:prstGeom prst="rect">
+            <a:avLst/>
+          </a:prstGeom>
+          <a:noFill/>
+          <a:ln/>
+        </p:spPr>
+        <p:txBody>
+          <a:bodyPr wrap="square" lIns="0" tIns="0" rIns="0" bIns="0" rtlCol="0" anchor="ctr"/>
+          <a:lstStyle/>
+          <a:p>
+            <a:pPr indent="0" marL="0">
+              <a:buNone/>
+            </a:pPr>
+            <a:r>
+              <a:rPr lang="en-US" sz="1300" dirty="0">
+                <a:solidFill>
+                  <a:srgbClr val="1B1B2F"/>
+                </a:solidFill>
+                <a:latin typeface="Calibri" pitchFamily="34" charset="0"/>
+                <a:ea typeface="Calibri" pitchFamily="34" charset="-122"/>
+                <a:cs typeface="Calibri" pitchFamily="34" charset="-120"/>
+              </a:rPr>
+              <a:t>Ground truths à faire valider par un référent métier (Sarah)</a:t>
+            </a:r>
+            <a:endParaRPr lang="en-US" sz="1300" dirty="0"/>
+          </a:p>
+        </p:txBody>
+      </p:sp>
+      <p:sp>
+        <p:nvSpPr>
+          <p:cNvPr id="15" name="Shape 10"/>
+          <p:cNvSpPr/>
+          <p:nvPr/>
+        </p:nvSpPr>
+        <p:spPr>
+          <a:xfrm>
+            <a:off x="548640" y="4617720"/>
+            <a:ext cx="502920" cy="502920"/>
+          </a:xfrm>
+          <a:prstGeom prst="ellipse">
+            <a:avLst/>
+          </a:prstGeom>
+          <a:solidFill>
+            <a:srgbClr val="F4F6FC"/>
+          </a:solidFill>
+          <a:ln/>
+        </p:spPr>
+      </p:sp>
+      <p:pic>
+        <p:nvPicPr>
+          <p:cNvPr id="16" name="Image 3" descr="/sessions/busy-trusting-darwin/mnt/outputs/pptx_build/icons/lightbulb_E8702A.png">    </p:cNvPr>
+          <p:cNvPicPr>
+            <a:picLocks noChangeAspect="1"/>
+          </p:cNvPicPr>
+          <p:nvPr/>
+        </p:nvPicPr>
+        <p:blipFill>
+          <a:blip r:embed="rId4"/>
+          <a:stretch>
+            <a:fillRect/>
+          </a:stretch>
+        </p:blipFill>
+        <p:spPr>
+          <a:xfrm>
+            <a:off x="614020" y="4683100"/>
+            <a:ext cx="372161" cy="372161"/>
+          </a:xfrm>
+          <a:prstGeom prst="rect">
+            <a:avLst/>
+          </a:prstGeom>
+        </p:spPr>
+      </p:pic>
+      <p:sp>
+        <p:nvSpPr>
+          <p:cNvPr id="17" name="Shape 11"/>
+          <p:cNvSpPr/>
+          <p:nvPr/>
+        </p:nvSpPr>
+        <p:spPr>
+          <a:xfrm>
+            <a:off x="1234440" y="4617720"/>
+            <a:ext cx="10424160" cy="777240"/>
+          </a:xfrm>
+          <a:prstGeom prst="roundRect">
+            <a:avLst>
+              <a:gd name="adj" fmla="val 9412"/>
+            </a:avLst>
+          </a:prstGeom>
+          <a:solidFill>
+            <a:srgbClr val="F9FAFB"/>
+          </a:solidFill>
+          <a:ln/>
+        </p:spPr>
+      </p:sp>
+      <p:sp>
+        <p:nvSpPr>
+          <p:cNvPr id="18" name="Text 12"/>
+          <p:cNvSpPr/>
+          <p:nvPr/>
+        </p:nvSpPr>
+        <p:spPr>
+          <a:xfrm>
+            <a:off x="1463040" y="4617720"/>
+            <a:ext cx="9966960" cy="777240"/>
+          </a:xfrm>
+          <a:prstGeom prst="rect">
+            <a:avLst/>
+          </a:prstGeom>
+          <a:noFill/>
+          <a:ln/>
+        </p:spPr>
+        <p:txBody>
+          <a:bodyPr wrap="square" lIns="0" tIns="0" rIns="0" bIns="0" rtlCol="0" anchor="ctr"/>
+          <a:lstStyle/>
+          <a:p>
+            <a:pPr indent="0" marL="0">
+              <a:buNone/>
+            </a:pPr>
+            <a:r>
+              <a:rPr lang="en-US" sz="1300" dirty="0">
+                <a:solidFill>
+                  <a:srgbClr val="1B1B2F"/>
+                </a:solidFill>
+                <a:latin typeface="Calibri" pitchFamily="34" charset="0"/>
+                <a:ea typeface="Calibri" pitchFamily="34" charset="-122"/>
+                <a:cs typeface="Calibri" pitchFamily="34" charset="-120"/>
+              </a:rPr>
+              <a:t>Coût / latence non mesurés — à ajouter pour un usage en production</a:t>
+            </a:r>
+            <a:endParaRPr lang="en-US" sz="1300" dirty="0"/>
+          </a:p>
+        </p:txBody>
+      </p:sp>
+      <p:sp>
+        <p:nvSpPr>
+          <p:cNvPr id="19" name="Text 13"/>
+          <p:cNvSpPr/>
+          <p:nvPr/>
+        </p:nvSpPr>
+        <p:spPr>
+          <a:xfrm>
+            <a:off x="548640" y="5715000"/>
+            <a:ext cx="11091672" cy="548640"/>
+          </a:xfrm>
+          <a:prstGeom prst="rect">
+            <a:avLst/>
+          </a:prstGeom>
+          <a:noFill/>
+          <a:ln/>
+        </p:spPr>
+        <p:txBody>
+          <a:bodyPr wrap="square" lIns="0" tIns="0" rIns="0" bIns="0" rtlCol="0" anchor="ctr"/>
+          <a:lstStyle/>
+          <a:p>
+            <a:pPr indent="0" marL="0">
+              <a:buNone/>
+            </a:pPr>
+            <a:r>
+              <a:rPr lang="en-US" sz="1200" i="1" dirty="0">
+                <a:solidFill>
+                  <a:srgbClr val="6B7280"/>
+                </a:solidFill>
+                <a:latin typeface="Calibri" pitchFamily="34" charset="0"/>
+                <a:ea typeface="Calibri" pitchFamily="34" charset="-122"/>
+                <a:cs typeface="Calibri" pitchFamily="34" charset="-120"/>
+              </a:rPr>
+              <a:t>Je préfère assumer ces limites explicitement plutôt que de présenter un score parfait qui ne résisterait pas à un examen approfondi.</a:t>
+            </a:r>
+            <a:endParaRPr lang="en-US" sz="1200" dirty="0"/>
+          </a:p>
+        </p:txBody>
+      </p:sp>
+      <p:sp>
+        <p:nvSpPr>
+          <p:cNvPr id="20" name="Text 14"/>
+          <p:cNvSpPr/>
+          <p:nvPr/>
+        </p:nvSpPr>
+        <p:spPr>
+          <a:xfrm>
+            <a:off x="548640" y="6537960"/>
+            <a:ext cx="5486400" cy="274320"/>
+          </a:xfrm>
+          <a:prstGeom prst="rect">
+            <a:avLst/>
+          </a:prstGeom>
+          <a:noFill/>
+          <a:ln/>
+        </p:spPr>
+        <p:txBody>
+          <a:bodyPr wrap="square" lIns="0" tIns="0" rIns="0" bIns="0" rtlCol="0" anchor="ctr"/>
+          <a:lstStyle/>
+          <a:p>
+            <a:pPr indent="0" marL="0">
+              <a:buNone/>
+            </a:pPr>
+            <a:r>
+              <a:rPr lang="en-US" sz="900" dirty="0">
+                <a:solidFill>
+                  <a:srgbClr val="6B7280"/>
+                </a:solidFill>
+                <a:latin typeface="Calibri" pitchFamily="34" charset="0"/>
+                <a:ea typeface="Calibri" pitchFamily="34" charset="-122"/>
+                <a:cs typeface="Calibri" pitchFamily="34" charset="-120"/>
+              </a:rPr>
+              <a:t>SportSee — NBA Analyst AI</a:t>
+            </a:r>
+            <a:endParaRPr lang="en-US" sz="900" dirty="0"/>
+          </a:p>
+        </p:txBody>
+      </p:sp>
+      <p:sp>
+        <p:nvSpPr>
+          <p:cNvPr id="21" name="Text 15"/>
+          <p:cNvSpPr/>
+          <p:nvPr/>
+        </p:nvSpPr>
+        <p:spPr>
+          <a:xfrm>
+            <a:off x="11338560" y="6537960"/>
+            <a:ext cx="365760" cy="274320"/>
+          </a:xfrm>
+          <a:prstGeom prst="rect">
+            <a:avLst/>
+          </a:prstGeom>
+          <a:noFill/>
+          <a:ln/>
+        </p:spPr>
+        <p:txBody>
+          <a:bodyPr wrap="square" lIns="0" tIns="0" rIns="0" bIns="0" rtlCol="0" anchor="ctr"/>
+          <a:lstStyle/>
+          <a:p>
+            <a:pPr algn="r" indent="0" marL="0">
+              <a:buNone/>
+            </a:pPr>
+            <a:r>
+              <a:rPr lang="en-US" sz="900" dirty="0">
+                <a:solidFill>
+                  <a:srgbClr val="6B7280"/>
+                </a:solidFill>
+                <a:latin typeface="Calibri" pitchFamily="34" charset="0"/>
+                <a:ea typeface="Calibri" pitchFamily="34" charset="-122"/>
+                <a:cs typeface="Calibri" pitchFamily="34" charset="-120"/>
+              </a:rPr>
+              <a:t>11</a:t>
+            </a:r>
+            <a:endParaRPr lang="en-US" sz="900" dirty="0"/>
+          </a:p>
+        </p:txBody>
+      </p:sp>
+    </p:spTree>
+  </p:cSld>
+  <p:clrMapOvr>
+    <a:masterClrMapping/>
+  </p:clrMapOvr>
+</p:sld>
+</file>
+
+<file path=ppt/slides/slide12.xml><?xml version="1.0" encoding="utf-8"?>
+<p:sld xmlns:a="http://schemas.openxmlformats.org/drawingml/2006/main" xmlns:r="http://schemas.openxmlformats.org/officeDocument/2006/relationships" xmlns:p="http://schemas.openxmlformats.org/presentationml/2006/main">
+  <p:cSld name="Slide 12">
     <p:bg>
       <p:bgPr>
         <a:solidFill>
@@ -4734,7 +5677,7 @@
                 <a:ea typeface="Calibri" pitchFamily="34" charset="-122"/>
                 <a:cs typeface="Calibri" pitchFamily="34" charset="-120"/>
               </a:rPr>
-              <a:t>NL → SQL sécurisé — SQLite</a:t>
+              <a:t>LangChain NL → SQL + garde-fous — PostgreSQL</a:t>
             </a:r>
             <a:endParaRPr lang="en-US" sz="1250" dirty="0"/>
           </a:p>
@@ -8166,7 +9109,7 @@
                 <a:ea typeface="Calibri" pitchFamily="34" charset="-122"/>
                 <a:cs typeface="Calibri" pitchFamily="34" charset="-120"/>
               </a:rPr>
-              <a:t>54 tests unitaires (pytest)</a:t>
+              <a:t>60 tests unitaires (pytest)</a:t>
             </a:r>
             <a:endParaRPr lang="en-US" sz="1350" dirty="0"/>
           </a:p>
@@ -8892,7 +9835,7 @@
                 <a:ea typeface="Cambria" pitchFamily="34" charset="-122"/>
                 <a:cs typeface="Cambria" pitchFamily="34" charset="-120"/>
               </a:rPr>
-              <a:t>OCR et visualisation dynamique</a:t>
+              <a:t>Observabilité : Pydantic Logfire</a:t>
             </a:r>
             <a:endParaRPr lang="en-US" sz="3200" dirty="0"/>
           </a:p>
@@ -8931,7 +9874,7 @@
                 <a:ea typeface="Calibri" pitchFamily="34" charset="-122"/>
                 <a:cs typeface="Calibri" pitchFamily="34" charset="-120"/>
               </a:rPr>
-              <a:t>Deux composants du système, au même niveau d’exigence que le SQL Tool</a:t>
+              <a:t>Chaque étape du pipeline tracée en continu, pas seulement au moment de l’évaluation</a:t>
             </a:r>
             <a:endParaRPr lang="en-US" sz="1400" dirty="0"/>
           </a:p>
@@ -8946,17 +9889,22 @@
         <p:spPr>
           <a:xfrm>
             <a:off x="548640" y="1508760"/>
-            <a:ext cx="5349240" cy="4480560"/>
+            <a:ext cx="11091672" cy="3794760"/>
           </a:xfrm>
           <a:prstGeom prst="roundRect">
             <a:avLst>
-              <a:gd name="adj" fmla="val 2041"/>
+              <a:gd name="adj" fmla="val 2410"/>
             </a:avLst>
           </a:prstGeom>
           <a:solidFill>
             <a:srgbClr val="F4F6FC"/>
           </a:solidFill>
-          <a:ln/>
+          <a:ln w="19050">
+            <a:solidFill>
+              <a:srgbClr val="CADCFC"/>
+            </a:solidFill>
+            <a:prstDash val="dash"/>
+          </a:ln>
         </p:spPr>
       </p:sp>
       <p:sp>
@@ -8967,21 +9915,21 @@
         </p:nvSpPr>
         <p:spPr>
           <a:xfrm>
-            <a:off x="822960" y="1783080"/>
-            <a:ext cx="640080" cy="640080"/>
+            <a:off x="5682996" y="2743200"/>
+            <a:ext cx="822960" cy="822960"/>
           </a:xfrm>
           <a:prstGeom prst="ellipse">
             <a:avLst/>
           </a:prstGeom>
           <a:solidFill>
-            <a:srgbClr val="1E2761"/>
+            <a:srgbClr val="FFFFFF"/>
           </a:solidFill>
           <a:ln/>
         </p:spPr>
       </p:sp>
       <p:pic>
         <p:nvPicPr>
-          <p:cNvPr id="6" name="Image 0" descr="/sessions/busy-trusting-darwin/mnt/outputs/pptx_build/icons/fileImage_FFFFFF.png">    </p:cNvPr>
+          <p:cNvPr id="6" name="Image 0" descr="/sessions/busy-trusting-darwin/mnt/outputs/pptx_build/icons/eye_1E2761.png">    </p:cNvPr>
           <p:cNvPicPr>
             <a:picLocks noChangeAspect="1"/>
           </p:cNvPicPr>
@@ -8995,8 +9943,8 @@
         </p:blipFill>
         <p:spPr>
           <a:xfrm>
-            <a:off x="906170" y="1866290"/>
-            <a:ext cx="473659" cy="473659"/>
+            <a:off x="5789981" y="2850185"/>
+            <a:ext cx="608990" cy="608990"/>
           </a:xfrm>
           <a:prstGeom prst="rect">
             <a:avLst/>
@@ -9011,20 +9959,20 @@
         </p:nvSpPr>
         <p:spPr>
           <a:xfrm>
-            <a:off x="1645920" y="1892808"/>
-            <a:ext cx="4023360" cy="457200"/>
-          </a:xfrm>
-          <a:prstGeom prst="rect">
-            <a:avLst/>
-          </a:prstGeom>
-          <a:noFill/>
-          <a:ln/>
-        </p:spPr>
-        <p:txBody>
-          <a:bodyPr wrap="square" lIns="0" tIns="0" rIns="0" bIns="0" rtlCol="0" anchor="ctr"/>
-          <a:lstStyle/>
-          <a:p>
-            <a:pPr indent="0" marL="0">
+            <a:off x="1005840" y="3794760"/>
+            <a:ext cx="10177272" cy="457200"/>
+          </a:xfrm>
+          <a:prstGeom prst="rect">
+            <a:avLst/>
+          </a:prstGeom>
+          <a:noFill/>
+          <a:ln/>
+        </p:spPr>
+        <p:txBody>
+          <a:bodyPr wrap="square" lIns="0" tIns="0" rIns="0" bIns="0" rtlCol="0" anchor="ctr"/>
+          <a:lstStyle/>
+          <a:p>
+            <a:pPr algn="ctr" indent="0" marL="0">
               <a:buNone/>
             </a:pPr>
             <a:r>
@@ -9036,7 +9984,7 @@
                 <a:ea typeface="Calibri" pitchFamily="34" charset="-122"/>
                 <a:cs typeface="Calibri" pitchFamily="34" charset="-120"/>
               </a:rPr>
-              <a:t>OCR — fallback Nanonets</a:t>
+              <a:t>Capture d’écran du dashboard Logfire à insérer ici</a:t>
             </a:r>
             <a:endParaRPr lang="en-US" sz="1500" dirty="0"/>
           </a:p>
@@ -9050,32 +9998,32 @@
         </p:nvSpPr>
         <p:spPr>
           <a:xfrm>
-            <a:off x="822960" y="2651760"/>
-            <a:ext cx="4800600" cy="548640"/>
-          </a:xfrm>
-          <a:prstGeom prst="rect">
-            <a:avLst/>
-          </a:prstGeom>
-          <a:noFill/>
-          <a:ln/>
-        </p:spPr>
-        <p:txBody>
-          <a:bodyPr wrap="square" lIns="0" tIns="0" rIns="0" bIns="0" rtlCol="0" anchor="ctr"/>
-          <a:lstStyle/>
-          <a:p>
-            <a:pPr indent="0" marL="0">
-              <a:buNone/>
-            </a:pPr>
-            <a:r>
-              <a:rPr lang="en-US" sz="1150" dirty="0">
-                <a:solidFill>
-                  <a:srgbClr val="1B1B2F"/>
-                </a:solidFill>
-                <a:latin typeface="Calibri" pitchFamily="34" charset="0"/>
-                <a:ea typeface="Calibri" pitchFamily="34" charset="-122"/>
-                <a:cs typeface="Calibri" pitchFamily="34" charset="-120"/>
-              </a:rPr>
-              <a:t>Fallback automatique quand un PDF n’a pas de couche de texte (rapport scanné).</a:t>
+            <a:off x="1005840" y="4297680"/>
+            <a:ext cx="10177272" cy="457200"/>
+          </a:xfrm>
+          <a:prstGeom prst="rect">
+            <a:avLst/>
+          </a:prstGeom>
+          <a:noFill/>
+          <a:ln/>
+        </p:spPr>
+        <p:txBody>
+          <a:bodyPr wrap="square" lIns="0" tIns="0" rIns="0" bIns="0" rtlCol="0" anchor="ctr"/>
+          <a:lstStyle/>
+          <a:p>
+            <a:pPr algn="ctr" indent="0" marL="0">
+              <a:buNone/>
+            </a:pPr>
+            <a:r>
+              <a:rPr lang="en-US" sz="1150" i="1" dirty="0">
+                <a:solidFill>
+                  <a:srgbClr val="6B7280"/>
+                </a:solidFill>
+                <a:latin typeface="Calibri" pitchFamily="34" charset="0"/>
+                <a:ea typeface="Calibri" pitchFamily="34" charset="-122"/>
+                <a:cs typeface="Calibri" pitchFamily="34" charset="-120"/>
+              </a:rPr>
+              <a:t>(remplacer ce bloc par une capture réelle du projet Logfire — ou faire une démonstration live pendant la soutenance)</a:t>
             </a:r>
             <a:endParaRPr lang="en-US" sz="1150" dirty="0"/>
           </a:p>
@@ -9083,317 +10031,19 @@
       </p:sp>
       <p:sp>
         <p:nvSpPr>
-          <p:cNvPr id="9" name="Text 6"/>
-          <p:cNvSpPr/>
-          <p:nvPr/>
-        </p:nvSpPr>
-        <p:spPr>
-          <a:xfrm>
-            <a:off x="914400" y="3383280"/>
-            <a:ext cx="1645920" cy="640080"/>
-          </a:xfrm>
-          <a:prstGeom prst="rect">
-            <a:avLst/>
-          </a:prstGeom>
-          <a:noFill/>
-          <a:ln/>
-        </p:spPr>
-        <p:txBody>
-          <a:bodyPr wrap="square" lIns="0" tIns="0" rIns="0" bIns="0" rtlCol="0" anchor="ctr"/>
-          <a:lstStyle/>
-          <a:p>
-            <a:pPr algn="ctr" indent="0" marL="0">
-              <a:buNone/>
-            </a:pPr>
-            <a:r>
-              <a:rPr lang="en-US" sz="3000" b="1" dirty="0">
-                <a:solidFill>
-                  <a:srgbClr val="6B7280"/>
-                </a:solidFill>
-                <a:latin typeface="Cambria" pitchFamily="34" charset="0"/>
-                <a:ea typeface="Cambria" pitchFamily="34" charset="-122"/>
-                <a:cs typeface="Cambria" pitchFamily="34" charset="-120"/>
-              </a:rPr>
-              <a:t>0,00</a:t>
-            </a:r>
-            <a:endParaRPr lang="en-US" sz="3000" dirty="0"/>
-          </a:p>
-        </p:txBody>
-      </p:sp>
-      <p:sp>
-        <p:nvSpPr>
-          <p:cNvPr id="10" name="Text 7"/>
-          <p:cNvSpPr/>
-          <p:nvPr/>
-        </p:nvSpPr>
-        <p:spPr>
-          <a:xfrm>
-            <a:off x="914400" y="3931920"/>
-            <a:ext cx="1645920" cy="320040"/>
-          </a:xfrm>
-          <a:prstGeom prst="rect">
-            <a:avLst/>
-          </a:prstGeom>
-          <a:noFill/>
-          <a:ln/>
-        </p:spPr>
-        <p:txBody>
-          <a:bodyPr wrap="square" lIns="0" tIns="0" rIns="0" bIns="0" rtlCol="0" anchor="ctr"/>
-          <a:lstStyle/>
-          <a:p>
-            <a:pPr algn="ctr" indent="0" marL="0">
-              <a:buNone/>
-            </a:pPr>
-            <a:r>
-              <a:rPr lang="en-US" sz="1000" dirty="0">
-                <a:solidFill>
-                  <a:srgbClr val="6B7280"/>
-                </a:solidFill>
-                <a:latin typeface="Calibri" pitchFamily="34" charset="0"/>
-                <a:ea typeface="Calibri" pitchFamily="34" charset="-122"/>
-                <a:cs typeface="Calibri" pitchFamily="34" charset="-120"/>
-              </a:rPr>
-              <a:t>avant</a:t>
-            </a:r>
-            <a:endParaRPr lang="en-US" sz="1000" dirty="0"/>
-          </a:p>
-        </p:txBody>
-      </p:sp>
-      <p:sp>
-        <p:nvSpPr>
-          <p:cNvPr id="11" name="Shape 8"/>
-          <p:cNvSpPr/>
-          <p:nvPr/>
-        </p:nvSpPr>
-        <p:spPr>
-          <a:xfrm>
-            <a:off x="2697480" y="3566160"/>
-            <a:ext cx="457200" cy="457200"/>
-          </a:xfrm>
-          <a:prstGeom prst="ellipse">
-            <a:avLst/>
-          </a:prstGeom>
-          <a:solidFill>
-            <a:srgbClr val="FFFFFF"/>
-          </a:solidFill>
-          <a:ln/>
-        </p:spPr>
-      </p:sp>
-      <p:pic>
-        <p:nvPicPr>
-          <p:cNvPr id="12" name="Image 1" descr="/sessions/busy-trusting-darwin/mnt/outputs/pptx_build/icons/arrowRight_E8702A.png">    </p:cNvPr>
-          <p:cNvPicPr>
-            <a:picLocks noChangeAspect="1"/>
-          </p:cNvPicPr>
-          <p:nvPr/>
-        </p:nvPicPr>
-        <p:blipFill>
-          <a:blip r:embed="rId2"/>
-          <a:stretch>
-            <a:fillRect/>
-          </a:stretch>
-        </p:blipFill>
-        <p:spPr>
-          <a:xfrm>
-            <a:off x="2756916" y="3625596"/>
-            <a:ext cx="338328" cy="338328"/>
-          </a:xfrm>
-          <a:prstGeom prst="rect">
-            <a:avLst/>
-          </a:prstGeom>
-        </p:spPr>
-      </p:pic>
-      <p:sp>
-        <p:nvSpPr>
-          <p:cNvPr id="13" name="Text 9"/>
-          <p:cNvSpPr/>
-          <p:nvPr/>
-        </p:nvSpPr>
-        <p:spPr>
-          <a:xfrm>
-            <a:off x="3291840" y="3383280"/>
-            <a:ext cx="1737360" cy="640080"/>
-          </a:xfrm>
-          <a:prstGeom prst="rect">
-            <a:avLst/>
-          </a:prstGeom>
-          <a:noFill/>
-          <a:ln/>
-        </p:spPr>
-        <p:txBody>
-          <a:bodyPr wrap="square" lIns="0" tIns="0" rIns="0" bIns="0" rtlCol="0" anchor="ctr"/>
-          <a:lstStyle/>
-          <a:p>
-            <a:pPr algn="ctr" indent="0" marL="0">
-              <a:buNone/>
-            </a:pPr>
-            <a:r>
-              <a:rPr lang="en-US" sz="3000" b="1" dirty="0">
-                <a:solidFill>
-                  <a:srgbClr val="E8702A"/>
-                </a:solidFill>
-                <a:latin typeface="Cambria" pitchFamily="34" charset="0"/>
-                <a:ea typeface="Cambria" pitchFamily="34" charset="-122"/>
-                <a:cs typeface="Cambria" pitchFamily="34" charset="-120"/>
-              </a:rPr>
-              <a:t>0,9757</a:t>
-            </a:r>
-            <a:endParaRPr lang="en-US" sz="3000" dirty="0"/>
-          </a:p>
-        </p:txBody>
-      </p:sp>
-      <p:sp>
-        <p:nvSpPr>
-          <p:cNvPr id="14" name="Text 10"/>
-          <p:cNvSpPr/>
-          <p:nvPr/>
-        </p:nvSpPr>
-        <p:spPr>
-          <a:xfrm>
-            <a:off x="3291840" y="3931920"/>
-            <a:ext cx="1737360" cy="320040"/>
-          </a:xfrm>
-          <a:prstGeom prst="rect">
-            <a:avLst/>
-          </a:prstGeom>
-          <a:noFill/>
-          <a:ln/>
-        </p:spPr>
-        <p:txBody>
-          <a:bodyPr wrap="square" lIns="0" tIns="0" rIns="0" bIns="0" rtlCol="0" anchor="ctr"/>
-          <a:lstStyle/>
-          <a:p>
-            <a:pPr algn="ctr" indent="0" marL="0">
-              <a:buNone/>
-            </a:pPr>
-            <a:r>
-              <a:rPr lang="en-US" sz="1000" dirty="0">
-                <a:solidFill>
-                  <a:srgbClr val="6B7280"/>
-                </a:solidFill>
-                <a:latin typeface="Calibri" pitchFamily="34" charset="0"/>
-                <a:ea typeface="Calibri" pitchFamily="34" charset="-122"/>
-                <a:cs typeface="Calibri" pitchFamily="34" charset="-120"/>
-              </a:rPr>
-              <a:t>après (similarité)</a:t>
-            </a:r>
-            <a:endParaRPr lang="en-US" sz="1000" dirty="0"/>
-          </a:p>
-        </p:txBody>
-      </p:sp>
-      <p:sp>
-        <p:nvSpPr>
-          <p:cNvPr id="15" name="Text 11"/>
-          <p:cNvSpPr/>
-          <p:nvPr/>
-        </p:nvSpPr>
-        <p:spPr>
-          <a:xfrm>
-            <a:off x="822960" y="4480560"/>
-            <a:ext cx="4800600" cy="822960"/>
-          </a:xfrm>
-          <a:prstGeom prst="rect">
-            <a:avLst/>
-          </a:prstGeom>
-          <a:noFill/>
-          <a:ln/>
-        </p:spPr>
-        <p:txBody>
-          <a:bodyPr wrap="square" lIns="0" tIns="0" rIns="0" bIns="0" rtlCol="0" anchor="ctr"/>
-          <a:lstStyle/>
-          <a:p>
-            <a:pPr indent="0" marL="0">
-              <a:buNone/>
-            </a:pPr>
-            <a:r>
-              <a:rPr lang="en-US" sz="1100" dirty="0">
-                <a:solidFill>
-                  <a:srgbClr val="1B1B2F"/>
-                </a:solidFill>
-                <a:latin typeface="Calibri" pitchFamily="34" charset="0"/>
-                <a:ea typeface="Calibri" pitchFamily="34" charset="-122"/>
-                <a:cs typeface="Calibri" pitchFamily="34" charset="-120"/>
-              </a:rPr>
-              <a:t>413 caractères restitués sur un document de test synthétique reproductible (evaluate_ocr.py) — amélioration de +0,98.</a:t>
-            </a:r>
-            <a:endParaRPr lang="en-US" sz="1100" dirty="0"/>
-          </a:p>
-        </p:txBody>
-      </p:sp>
-      <p:sp>
-        <p:nvSpPr>
-          <p:cNvPr id="16" name="Text 12"/>
-          <p:cNvSpPr/>
-          <p:nvPr/>
-        </p:nvSpPr>
-        <p:spPr>
-          <a:xfrm>
-            <a:off x="822960" y="5349240"/>
-            <a:ext cx="4800600" cy="457200"/>
-          </a:xfrm>
-          <a:prstGeom prst="rect">
-            <a:avLst/>
-          </a:prstGeom>
-          <a:noFill/>
-          <a:ln/>
-        </p:spPr>
-        <p:txBody>
-          <a:bodyPr wrap="square" lIns="0" tIns="0" rIns="0" bIns="0" rtlCol="0" anchor="ctr"/>
-          <a:lstStyle/>
-          <a:p>
-            <a:pPr indent="0" marL="0">
-              <a:buNone/>
-            </a:pPr>
-            <a:r>
-              <a:rPr lang="en-US" sz="1050" i="1" dirty="0">
-                <a:solidFill>
-                  <a:srgbClr val="6B7280"/>
-                </a:solidFill>
-                <a:latin typeface="Calibri" pitchFamily="34" charset="0"/>
-                <a:ea typeface="Calibri" pitchFamily="34" charset="-122"/>
-                <a:cs typeface="Calibri" pitchFamily="34" charset="-120"/>
-              </a:rPr>
-              <a:t>Sans clé API : désactivation propre, aucun crash.</a:t>
-            </a:r>
-            <a:endParaRPr lang="en-US" sz="1050" dirty="0"/>
-          </a:p>
-        </p:txBody>
-      </p:sp>
-      <p:sp>
-        <p:nvSpPr>
-          <p:cNvPr id="17" name="Shape 13"/>
-          <p:cNvSpPr/>
-          <p:nvPr/>
-        </p:nvSpPr>
-        <p:spPr>
-          <a:xfrm>
-            <a:off x="6291072" y="1508760"/>
-            <a:ext cx="5349240" cy="4480560"/>
+          <p:cNvPr id="9" name="Shape 6"/>
+          <p:cNvSpPr/>
+          <p:nvPr/>
+        </p:nvSpPr>
+        <p:spPr>
+          <a:xfrm>
+            <a:off x="548640" y="5486400"/>
+            <a:ext cx="11091672" cy="777240"/>
           </a:xfrm>
           <a:prstGeom prst="roundRect">
             <a:avLst>
-              <a:gd name="adj" fmla="val 2041"/>
+              <a:gd name="adj" fmla="val 9412"/>
             </a:avLst>
-          </a:prstGeom>
-          <a:solidFill>
-            <a:srgbClr val="F4F6FC"/>
-          </a:solidFill>
-          <a:ln/>
-        </p:spPr>
-      </p:sp>
-      <p:sp>
-        <p:nvSpPr>
-          <p:cNvPr id="18" name="Shape 14"/>
-          <p:cNvSpPr/>
-          <p:nvPr/>
-        </p:nvSpPr>
-        <p:spPr>
-          <a:xfrm>
-            <a:off x="6565392" y="1783080"/>
-            <a:ext cx="640080" cy="640080"/>
-          </a:xfrm>
-          <a:prstGeom prst="ellipse">
-            <a:avLst/>
           </a:prstGeom>
           <a:solidFill>
             <a:srgbClr val="1E2761"/>
@@ -9401,40 +10051,16 @@
           <a:ln/>
         </p:spPr>
       </p:sp>
-      <p:pic>
-        <p:nvPicPr>
-          <p:cNvPr id="19" name="Image 2" descr="/sessions/busy-trusting-darwin/mnt/outputs/pptx_build/icons/chartPie_FFFFFF.png">    </p:cNvPr>
-          <p:cNvPicPr>
-            <a:picLocks noChangeAspect="1"/>
-          </p:cNvPicPr>
-          <p:nvPr/>
-        </p:nvPicPr>
-        <p:blipFill>
-          <a:blip r:embed="rId3"/>
-          <a:stretch>
-            <a:fillRect/>
-          </a:stretch>
-        </p:blipFill>
-        <p:spPr>
-          <a:xfrm>
-            <a:off x="6648602" y="1866290"/>
-            <a:ext cx="473659" cy="473659"/>
-          </a:xfrm>
-          <a:prstGeom prst="rect">
-            <a:avLst/>
-          </a:prstGeom>
-        </p:spPr>
-      </p:pic>
-      <p:sp>
-        <p:nvSpPr>
-          <p:cNvPr id="20" name="Text 15"/>
-          <p:cNvSpPr/>
-          <p:nvPr/>
-        </p:nvSpPr>
-        <p:spPr>
-          <a:xfrm>
-            <a:off x="7388352" y="1892808"/>
-            <a:ext cx="4023360" cy="457200"/>
+      <p:sp>
+        <p:nvSpPr>
+          <p:cNvPr id="10" name="Text 7"/>
+          <p:cNvSpPr/>
+          <p:nvPr/>
+        </p:nvSpPr>
+        <p:spPr>
+          <a:xfrm>
+            <a:off x="822960" y="5486400"/>
+            <a:ext cx="10515600" cy="777240"/>
           </a:xfrm>
           <a:prstGeom prst="rect">
             <a:avLst/>
@@ -9450,54 +10076,15 @@
               <a:buNone/>
             </a:pPr>
             <a:r>
-              <a:rPr lang="en-US" sz="1400" b="1" dirty="0">
-                <a:solidFill>
-                  <a:srgbClr val="1E2761"/>
-                </a:solidFill>
-                <a:latin typeface="Calibri" pitchFamily="34" charset="0"/>
-                <a:ea typeface="Calibri" pitchFamily="34" charset="-122"/>
-                <a:cs typeface="Calibri" pitchFamily="34" charset="-120"/>
-              </a:rPr>
-              <a:t>PlotTool — graphiques dynamiques</a:t>
-            </a:r>
-            <a:endParaRPr lang="en-US" sz="1400" dirty="0"/>
-          </a:p>
-        </p:txBody>
-      </p:sp>
-      <p:sp>
-        <p:nvSpPr>
-          <p:cNvPr id="21" name="Text 16"/>
-          <p:cNvSpPr/>
-          <p:nvPr/>
-        </p:nvSpPr>
-        <p:spPr>
-          <a:xfrm>
-            <a:off x="6565392" y="2651760"/>
-            <a:ext cx="4800600" cy="731520"/>
-          </a:xfrm>
-          <a:prstGeom prst="rect">
-            <a:avLst/>
-          </a:prstGeom>
-          <a:noFill/>
-          <a:ln/>
-        </p:spPr>
-        <p:txBody>
-          <a:bodyPr wrap="square" lIns="0" tIns="0" rIns="0" bIns="0" rtlCol="0" anchor="ctr"/>
-          <a:lstStyle/>
-          <a:p>
-            <a:pPr indent="0" marL="0">
-              <a:buNone/>
-            </a:pPr>
-            <a:r>
-              <a:rPr lang="en-US" sz="1150" dirty="0">
-                <a:solidFill>
-                  <a:srgbClr val="1B1B2F"/>
-                </a:solidFill>
-                <a:latin typeface="Calibri" pitchFamily="34" charset="0"/>
-                <a:ea typeface="Calibri" pitchFamily="34" charset="-122"/>
-                <a:cs typeface="Calibri" pitchFamily="34" charset="-120"/>
-              </a:rPr>
-              <a:t>Le chatbot produit un graphique (barres / courbe / camembert) sur demande explicite (« montre un graphique de… »).</a:t>
+              <a:rPr lang="en-US" sz="1150" b="1" dirty="0">
+                <a:solidFill>
+                  <a:srgbClr val="FFFFFF"/>
+                </a:solidFill>
+                <a:latin typeface="Calibri" pitchFamily="34" charset="0"/>
+                <a:ea typeface="Calibri" pitchFamily="34" charset="-122"/>
+                <a:cs typeface="Calibri" pitchFamily="34" charset="-120"/>
+              </a:rPr>
+              <a:t>Étapes tracées : recherche vectorielle (FAISS), génération + exécution SQL (LangChain), génération finale (Mistral), erreurs et repli (fallback direct Mistral, garde-fous rejetés).</a:t>
             </a:r>
             <a:endParaRPr lang="en-US" sz="1150" dirty="0"/>
           </a:p>
@@ -9505,107 +10092,7 @@
       </p:sp>
       <p:sp>
         <p:nvSpPr>
-          <p:cNvPr id="22" name="Shape 17"/>
-          <p:cNvSpPr/>
-          <p:nvPr/>
-        </p:nvSpPr>
-        <p:spPr>
-          <a:xfrm>
-            <a:off x="6565392" y="3566160"/>
-            <a:ext cx="4800600" cy="1371600"/>
-          </a:xfrm>
-          <a:prstGeom prst="roundRect">
-            <a:avLst>
-              <a:gd name="adj" fmla="val 5333"/>
-            </a:avLst>
-          </a:prstGeom>
-          <a:solidFill>
-            <a:srgbClr val="1E2761"/>
-          </a:solidFill>
-          <a:ln/>
-        </p:spPr>
-      </p:sp>
-      <p:sp>
-        <p:nvSpPr>
-          <p:cNvPr id="23" name="Text 18"/>
-          <p:cNvSpPr/>
-          <p:nvPr/>
-        </p:nvSpPr>
-        <p:spPr>
-          <a:xfrm>
-            <a:off x="6793992" y="3566160"/>
-            <a:ext cx="4343400" cy="1371600"/>
-          </a:xfrm>
-          <a:prstGeom prst="rect">
-            <a:avLst/>
-          </a:prstGeom>
-          <a:noFill/>
-          <a:ln/>
-        </p:spPr>
-        <p:txBody>
-          <a:bodyPr wrap="square" lIns="0" tIns="0" rIns="0" bIns="0" rtlCol="0" anchor="ctr"/>
-          <a:lstStyle/>
-          <a:p>
-            <a:pPr indent="0" marL="0">
-              <a:buNone/>
-            </a:pPr>
-            <a:r>
-              <a:rPr lang="en-US" sz="1200" b="1" dirty="0">
-                <a:solidFill>
-                  <a:srgbClr val="FFFFFF"/>
-                </a:solidFill>
-                <a:latin typeface="Calibri" pitchFamily="34" charset="0"/>
-                <a:ea typeface="Calibri" pitchFamily="34" charset="-122"/>
-                <a:cs typeface="Calibri" pitchFamily="34" charset="-120"/>
-              </a:rPr>
-              <a:t>Garde-fou : le PlotTool ne réutilise QUE les données déjà validées par le SQL Tool — il ne peut pas inventer une valeur.</a:t>
-            </a:r>
-            <a:endParaRPr lang="en-US" sz="1200" dirty="0"/>
-          </a:p>
-        </p:txBody>
-      </p:sp>
-      <p:sp>
-        <p:nvSpPr>
-          <p:cNvPr id="24" name="Text 19"/>
-          <p:cNvSpPr/>
-          <p:nvPr/>
-        </p:nvSpPr>
-        <p:spPr>
-          <a:xfrm>
-            <a:off x="6565392" y="5166360"/>
-            <a:ext cx="4800600" cy="640080"/>
-          </a:xfrm>
-          <a:prstGeom prst="rect">
-            <a:avLst/>
-          </a:prstGeom>
-          <a:noFill/>
-          <a:ln/>
-        </p:spPr>
-        <p:txBody>
-          <a:bodyPr wrap="square" lIns="0" tIns="0" rIns="0" bIns="0" rtlCol="0" anchor="ctr"/>
-          <a:lstStyle/>
-          <a:p>
-            <a:pPr indent="0" marL="0">
-              <a:buNone/>
-            </a:pPr>
-            <a:r>
-              <a:rPr lang="en-US" sz="1050" i="1" dirty="0">
-                <a:solidFill>
-                  <a:srgbClr val="6B7280"/>
-                </a:solidFill>
-                <a:latin typeface="Calibri" pitchFamily="34" charset="0"/>
-                <a:ea typeface="Calibri" pitchFamily="34" charset="-122"/>
-                <a:cs typeface="Calibri" pitchFamily="34" charset="-120"/>
-              </a:rPr>
-              <a:t>Seul le type de graphique est choisi automatiquement (heuristique, sans appel LLM supplémentaire).</a:t>
-            </a:r>
-            <a:endParaRPr lang="en-US" sz="1050" dirty="0"/>
-          </a:p>
-        </p:txBody>
-      </p:sp>
-      <p:sp>
-        <p:nvSpPr>
-          <p:cNvPr id="25" name="Text 20"/>
+          <p:cNvPr id="11" name="Text 8"/>
           <p:cNvSpPr/>
           <p:nvPr/>
         </p:nvSpPr>
@@ -9644,7 +10131,7 @@
       </p:sp>
       <p:sp>
         <p:nvSpPr>
-          <p:cNvPr id="26" name="Text 21"/>
+          <p:cNvPr id="12" name="Text 9"/>
           <p:cNvSpPr/>
           <p:nvPr/>
         </p:nvSpPr>

</xml_diff>

<commit_message>
Resultats RAGAS post-migration LangChain + PostgreSQL
</commit_message>
<xml_diff>
--- a/Soutenance_SportSee_NBA_Analyst_AI.pptx
+++ b/Soutenance_SportSee_NBA_Analyst_AI.pptx
@@ -299,16 +299,16 @@
                 <c:formatCode>General</c:formatCode>
                 <c:ptCount val="4"/>
                 <c:pt idx="0">
-                  <c:v>0.673</c:v>
+                  <c:v>0.757</c:v>
                 </c:pt>
                 <c:pt idx="1">
-                  <c:v>0.581</c:v>
+                  <c:v>0.535</c:v>
                 </c:pt>
                 <c:pt idx="2">
-                  <c:v>0.403</c:v>
+                  <c:v>0.366</c:v>
                 </c:pt>
                 <c:pt idx="3">
-                  <c:v>0.577</c:v>
+                  <c:v>0.615</c:v>
                 </c:pt>
               </c:numCache>
             </c:numRef>
@@ -1490,7 +1490,7 @@
           <a:p>
             <a:r>
               <a:rPr lang="en-US" dirty="0"/>
-              <a:t>Le SQL Tool améliore nettement 3 métriques sur 4. La pertinence des réponses (+0,29) et le rappel du contexte (+0,23) progressent fortement : le système trouve et utilise mieux l'information nécessaire. La faithfulness recule, j'y reviens dans deux slides — ce n'est pas ce que ça semble être au premier regard.</a:t>
+              <a:t>Le SQL Tool améliore nettement 3 métriques sur 4. La pertinence des réponses (+0,24) et le rappel du contexte (+0,27) progressent fortement : le système trouve et utilise mieux l'information nécessaire. La faithfulness recule, j'y reviens dans deux slides — ce n'est pas ce que ça semble être au premier regard.</a:t>
             </a:r>
             <a:endParaRPr lang="en-US" dirty="0"/>
           </a:p>
@@ -7208,7 +7208,7 @@
                 <a:ea typeface="Calibri" pitchFamily="34" charset="-122"/>
                 <a:cs typeface="Calibri" pitchFamily="34" charset="-120"/>
               </a:rPr>
-              <a:t>answer_relevancy +0,286, context_recall +0,231, context_precision +0,129. La faithfulness recule (–0,194) — expliqué diapo suivante.</a:t>
+              <a:t>answer_relevancy +0,240, context_recall +0,269, context_precision +0,092. La faithfulness recule (–0,110) — expliqué diapo suivante.</a:t>
             </a:r>
             <a:endParaRPr lang="en-US" sz="1150" dirty="0"/>
           </a:p>

</xml_diff>